<commit_message>
docs(slides): ordena integrantes em ordem alfabética na apresentação T2
</commit_message>
<xml_diff>
--- a/docs/slides/RabbitMQ_Apresentacao.pptx
+++ b/docs/slides/RabbitMQ_Apresentacao.pptx
@@ -3423,7 +3423,7 @@
                 </a:solidFill>
                 <a:latin typeface="Calibri"/>
               </a:rPr>
-              <a:t>Caroline da Rocha de Lima  ·  Giovani da Silva Cancherini  ·  Arthur Real Sanchotene Ferreira</a:t>
+              <a:t>Arthur Real Sanchotene Ferreira  ·  Caroline da Rocha de Lima  ·  Giovani da Silva Cancherini</a:t>
             </a:r>
           </a:p>
         </p:txBody>
@@ -3458,7 +3458,7 @@
                 </a:solidFill>
                 <a:latin typeface="Calibri"/>
               </a:rPr>
-              <a:t>Osmar Sadi Nether Filho  ·  Leonardo Vargas Schilling</a:t>
+              <a:t>Leonardo Vargas Schilling  ·  Osmar Sadi Nether Filho</a:t>
             </a:r>
           </a:p>
         </p:txBody>

</xml_diff>

<commit_message>
docs(slides): update RabbitMQ presentation with new content
</commit_message>
<xml_diff>
--- a/docs/slides/RabbitMQ_Apresentacao.pptx
+++ b/docs/slides/RabbitMQ_Apresentacao.pptx
@@ -5,33 +5,33 @@
     <p:sldMasterId id="2147483648" r:id="rId1"/>
   </p:sldMasterIdLst>
   <p:sldIdLst>
-    <p:sldId id="256" r:id="rId7"/>
-    <p:sldId id="257" r:id="rId8"/>
-    <p:sldId id="258" r:id="rId9"/>
-    <p:sldId id="259" r:id="rId10"/>
-    <p:sldId id="260" r:id="rId11"/>
-    <p:sldId id="261" r:id="rId12"/>
-    <p:sldId id="262" r:id="rId13"/>
-    <p:sldId id="263" r:id="rId14"/>
-    <p:sldId id="264" r:id="rId15"/>
-    <p:sldId id="265" r:id="rId16"/>
-    <p:sldId id="266" r:id="rId17"/>
-    <p:sldId id="267" r:id="rId18"/>
-    <p:sldId id="268" r:id="rId19"/>
-    <p:sldId id="269" r:id="rId20"/>
-    <p:sldId id="270" r:id="rId21"/>
-    <p:sldId id="271" r:id="rId22"/>
-    <p:sldId id="272" r:id="rId23"/>
-    <p:sldId id="273" r:id="rId24"/>
-    <p:sldId id="274" r:id="rId25"/>
-    <p:sldId id="275" r:id="rId26"/>
-    <p:sldId id="276" r:id="rId27"/>
-    <p:sldId id="277" r:id="rId28"/>
-    <p:sldId id="278" r:id="rId29"/>
-    <p:sldId id="279" r:id="rId30"/>
-    <p:sldId id="280" r:id="rId31"/>
+    <p:sldId id="256" r:id="rId2"/>
+    <p:sldId id="257" r:id="rId3"/>
+    <p:sldId id="258" r:id="rId4"/>
+    <p:sldId id="259" r:id="rId5"/>
+    <p:sldId id="260" r:id="rId6"/>
+    <p:sldId id="261" r:id="rId7"/>
+    <p:sldId id="262" r:id="rId8"/>
+    <p:sldId id="263" r:id="rId9"/>
+    <p:sldId id="264" r:id="rId10"/>
+    <p:sldId id="265" r:id="rId11"/>
+    <p:sldId id="266" r:id="rId12"/>
+    <p:sldId id="267" r:id="rId13"/>
+    <p:sldId id="268" r:id="rId14"/>
+    <p:sldId id="269" r:id="rId15"/>
+    <p:sldId id="270" r:id="rId16"/>
+    <p:sldId id="271" r:id="rId17"/>
+    <p:sldId id="272" r:id="rId18"/>
+    <p:sldId id="273" r:id="rId19"/>
+    <p:sldId id="274" r:id="rId20"/>
+    <p:sldId id="275" r:id="rId21"/>
+    <p:sldId id="276" r:id="rId22"/>
+    <p:sldId id="277" r:id="rId23"/>
+    <p:sldId id="278" r:id="rId24"/>
+    <p:sldId id="279" r:id="rId25"/>
+    <p:sldId id="280" r:id="rId26"/>
   </p:sldIdLst>
-  <p:sldSz cx="12188952" cy="6858000" type="screen4x3"/>
+  <p:sldSz cx="12188825" cy="6858000"/>
   <p:notesSz cx="6858000" cy="9144000"/>
   <p:defaultTextStyle>
     <a:defPPr>
@@ -128,6 +128,22 @@
       </a:defRPr>
     </a:lvl9pPr>
   </p:defaultTextStyle>
+  <p:extLst>
+    <p:ext uri="{EFAFB233-063F-42B5-8137-9DF3F51BA10A}">
+      <p15:sldGuideLst xmlns:p15="http://schemas.microsoft.com/office/powerpoint/2012/main">
+        <p15:guide id="1" orient="horz" pos="2160">
+          <p15:clr>
+            <a:srgbClr val="A4A3A4"/>
+          </p15:clr>
+        </p15:guide>
+        <p15:guide id="2" pos="2880">
+          <p15:clr>
+            <a:srgbClr val="A4A3A4"/>
+          </p15:clr>
+        </p15:guide>
+      </p15:sldGuideLst>
+    </p:ext>
+  </p:extLst>
 </p:presentation>
 </file>
 
@@ -169,10 +185,9 @@
           <a:lstStyle/>
           <a:p>
             <a:r>
-              <a:rPr lang="en-US" smtClean="0"/>
+              <a:rPr lang="en-US"/>
               <a:t>Click to edit Master title style</a:t>
             </a:r>
-            <a:endParaRPr lang="en-US"/>
           </a:p>
         </p:txBody>
       </p:sp>
@@ -288,10 +303,9 @@
           </a:lstStyle>
           <a:p>
             <a:r>
-              <a:rPr lang="en-US" smtClean="0"/>
+              <a:rPr lang="en-US"/>
               <a:t>Click to edit Master subtitle style</a:t>
             </a:r>
-            <a:endParaRPr lang="en-US"/>
           </a:p>
         </p:txBody>
       </p:sp>
@@ -312,7 +326,7 @@
           <a:p>
             <a:fld id="{5BCAD085-E8A6-8845-BD4E-CB4CCA059FC4}" type="datetimeFigureOut">
               <a:rPr lang="en-US" smtClean="0"/>
-              <a:t>1/27/13</a:t>
+              <a:t>6/22/2026</a:t>
             </a:fld>
             <a:endParaRPr lang="en-US"/>
           </a:p>
@@ -354,7 +368,7 @@
           <a:p>
             <a:fld id="{C1FF6DA9-008F-8B48-92A6-B652298478BF}" type="slidenum">
               <a:rPr lang="en-US" smtClean="0"/>
-              <a:t>‹#›</a:t>
+              <a:t>‹nº›</a:t>
             </a:fld>
             <a:endParaRPr lang="en-US"/>
           </a:p>
@@ -406,10 +420,9 @@
           <a:lstStyle/>
           <a:p>
             <a:r>
-              <a:rPr lang="en-US" smtClean="0"/>
+              <a:rPr lang="en-US"/>
               <a:t>Click to edit Master title style</a:t>
             </a:r>
-            <a:endParaRPr lang="en-US"/>
           </a:p>
         </p:txBody>
       </p:sp>
@@ -430,38 +443,37 @@
           <a:p>
             <a:pPr lvl="0"/>
             <a:r>
-              <a:rPr lang="en-US" smtClean="0"/>
+              <a:rPr lang="en-US"/>
               <a:t>Click to edit Master text styles</a:t>
             </a:r>
           </a:p>
           <a:p>
             <a:pPr lvl="1"/>
             <a:r>
-              <a:rPr lang="en-US" smtClean="0"/>
+              <a:rPr lang="en-US"/>
               <a:t>Second level</a:t>
             </a:r>
           </a:p>
           <a:p>
             <a:pPr lvl="2"/>
             <a:r>
-              <a:rPr lang="en-US" smtClean="0"/>
+              <a:rPr lang="en-US"/>
               <a:t>Third level</a:t>
             </a:r>
           </a:p>
           <a:p>
             <a:pPr lvl="3"/>
             <a:r>
-              <a:rPr lang="en-US" smtClean="0"/>
+              <a:rPr lang="en-US"/>
               <a:t>Fourth level</a:t>
             </a:r>
           </a:p>
           <a:p>
             <a:pPr lvl="4"/>
             <a:r>
-              <a:rPr lang="en-US" smtClean="0"/>
+              <a:rPr lang="en-US"/>
               <a:t>Fifth level</a:t>
             </a:r>
-            <a:endParaRPr lang="en-US"/>
           </a:p>
         </p:txBody>
       </p:sp>
@@ -482,7 +494,7 @@
           <a:p>
             <a:fld id="{5BCAD085-E8A6-8845-BD4E-CB4CCA059FC4}" type="datetimeFigureOut">
               <a:rPr lang="en-US" smtClean="0"/>
-              <a:t>1/27/13</a:t>
+              <a:t>6/22/2026</a:t>
             </a:fld>
             <a:endParaRPr lang="en-US"/>
           </a:p>
@@ -524,7 +536,7 @@
           <a:p>
             <a:fld id="{C1FF6DA9-008F-8B48-92A6-B652298478BF}" type="slidenum">
               <a:rPr lang="en-US" smtClean="0"/>
-              <a:t>‹#›</a:t>
+              <a:t>‹nº›</a:t>
             </a:fld>
             <a:endParaRPr lang="en-US"/>
           </a:p>
@@ -581,10 +593,9 @@
           <a:lstStyle/>
           <a:p>
             <a:r>
-              <a:rPr lang="en-US" smtClean="0"/>
+              <a:rPr lang="en-US"/>
               <a:t>Click to edit Master title style</a:t>
             </a:r>
-            <a:endParaRPr lang="en-US"/>
           </a:p>
         </p:txBody>
       </p:sp>
@@ -610,38 +621,37 @@
           <a:p>
             <a:pPr lvl="0"/>
             <a:r>
-              <a:rPr lang="en-US" smtClean="0"/>
+              <a:rPr lang="en-US"/>
               <a:t>Click to edit Master text styles</a:t>
             </a:r>
           </a:p>
           <a:p>
             <a:pPr lvl="1"/>
             <a:r>
-              <a:rPr lang="en-US" smtClean="0"/>
+              <a:rPr lang="en-US"/>
               <a:t>Second level</a:t>
             </a:r>
           </a:p>
           <a:p>
             <a:pPr lvl="2"/>
             <a:r>
-              <a:rPr lang="en-US" smtClean="0"/>
+              <a:rPr lang="en-US"/>
               <a:t>Third level</a:t>
             </a:r>
           </a:p>
           <a:p>
             <a:pPr lvl="3"/>
             <a:r>
-              <a:rPr lang="en-US" smtClean="0"/>
+              <a:rPr lang="en-US"/>
               <a:t>Fourth level</a:t>
             </a:r>
           </a:p>
           <a:p>
             <a:pPr lvl="4"/>
             <a:r>
-              <a:rPr lang="en-US" smtClean="0"/>
+              <a:rPr lang="en-US"/>
               <a:t>Fifth level</a:t>
             </a:r>
-            <a:endParaRPr lang="en-US"/>
           </a:p>
         </p:txBody>
       </p:sp>
@@ -662,7 +672,7 @@
           <a:p>
             <a:fld id="{5BCAD085-E8A6-8845-BD4E-CB4CCA059FC4}" type="datetimeFigureOut">
               <a:rPr lang="en-US" smtClean="0"/>
-              <a:t>1/27/13</a:t>
+              <a:t>6/22/2026</a:t>
             </a:fld>
             <a:endParaRPr lang="en-US"/>
           </a:p>
@@ -704,7 +714,7 @@
           <a:p>
             <a:fld id="{C1FF6DA9-008F-8B48-92A6-B652298478BF}" type="slidenum">
               <a:rPr lang="en-US" smtClean="0"/>
-              <a:t>‹#›</a:t>
+              <a:t>‹nº›</a:t>
             </a:fld>
             <a:endParaRPr lang="en-US"/>
           </a:p>
@@ -756,10 +766,9 @@
           <a:lstStyle/>
           <a:p>
             <a:r>
-              <a:rPr lang="en-US" smtClean="0"/>
+              <a:rPr lang="en-US"/>
               <a:t>Click to edit Master title style</a:t>
             </a:r>
-            <a:endParaRPr lang="en-US"/>
           </a:p>
         </p:txBody>
       </p:sp>
@@ -780,38 +789,37 @@
           <a:p>
             <a:pPr lvl="0"/>
             <a:r>
-              <a:rPr lang="en-US" smtClean="0"/>
+              <a:rPr lang="en-US"/>
               <a:t>Click to edit Master text styles</a:t>
             </a:r>
           </a:p>
           <a:p>
             <a:pPr lvl="1"/>
             <a:r>
-              <a:rPr lang="en-US" smtClean="0"/>
+              <a:rPr lang="en-US"/>
               <a:t>Second level</a:t>
             </a:r>
           </a:p>
           <a:p>
             <a:pPr lvl="2"/>
             <a:r>
-              <a:rPr lang="en-US" smtClean="0"/>
+              <a:rPr lang="en-US"/>
               <a:t>Third level</a:t>
             </a:r>
           </a:p>
           <a:p>
             <a:pPr lvl="3"/>
             <a:r>
-              <a:rPr lang="en-US" smtClean="0"/>
+              <a:rPr lang="en-US"/>
               <a:t>Fourth level</a:t>
             </a:r>
           </a:p>
           <a:p>
             <a:pPr lvl="4"/>
             <a:r>
-              <a:rPr lang="en-US" smtClean="0"/>
+              <a:rPr lang="en-US"/>
               <a:t>Fifth level</a:t>
             </a:r>
-            <a:endParaRPr lang="en-US"/>
           </a:p>
         </p:txBody>
       </p:sp>
@@ -832,7 +840,7 @@
           <a:p>
             <a:fld id="{5BCAD085-E8A6-8845-BD4E-CB4CCA059FC4}" type="datetimeFigureOut">
               <a:rPr lang="en-US" smtClean="0"/>
-              <a:t>1/27/13</a:t>
+              <a:t>6/22/2026</a:t>
             </a:fld>
             <a:endParaRPr lang="en-US"/>
           </a:p>
@@ -874,7 +882,7 @@
           <a:p>
             <a:fld id="{C1FF6DA9-008F-8B48-92A6-B652298478BF}" type="slidenum">
               <a:rPr lang="en-US" smtClean="0"/>
-              <a:t>‹#›</a:t>
+              <a:t>‹nº›</a:t>
             </a:fld>
             <a:endParaRPr lang="en-US"/>
           </a:p>
@@ -935,10 +943,9 @@
           </a:lstStyle>
           <a:p>
             <a:r>
-              <a:rPr lang="en-US" smtClean="0"/>
+              <a:rPr lang="en-US"/>
               <a:t>Click to edit Master title style</a:t>
             </a:r>
-            <a:endParaRPr lang="en-US"/>
           </a:p>
         </p:txBody>
       </p:sp>
@@ -1055,7 +1062,7 @@
           <a:p>
             <a:pPr lvl="0"/>
             <a:r>
-              <a:rPr lang="en-US" smtClean="0"/>
+              <a:rPr lang="en-US"/>
               <a:t>Click to edit Master text styles</a:t>
             </a:r>
           </a:p>
@@ -1078,7 +1085,7 @@
           <a:p>
             <a:fld id="{5BCAD085-E8A6-8845-BD4E-CB4CCA059FC4}" type="datetimeFigureOut">
               <a:rPr lang="en-US" smtClean="0"/>
-              <a:t>1/27/13</a:t>
+              <a:t>6/22/2026</a:t>
             </a:fld>
             <a:endParaRPr lang="en-US"/>
           </a:p>
@@ -1120,7 +1127,7 @@
           <a:p>
             <a:fld id="{C1FF6DA9-008F-8B48-92A6-B652298478BF}" type="slidenum">
               <a:rPr lang="en-US" smtClean="0"/>
-              <a:t>‹#›</a:t>
+              <a:t>‹nº›</a:t>
             </a:fld>
             <a:endParaRPr lang="en-US"/>
           </a:p>
@@ -1172,10 +1179,9 @@
           <a:lstStyle/>
           <a:p>
             <a:r>
-              <a:rPr lang="en-US" smtClean="0"/>
+              <a:rPr lang="en-US"/>
               <a:t>Click to edit Master title style</a:t>
             </a:r>
-            <a:endParaRPr lang="en-US"/>
           </a:p>
         </p:txBody>
       </p:sp>
@@ -1229,38 +1235,37 @@
           <a:p>
             <a:pPr lvl="0"/>
             <a:r>
-              <a:rPr lang="en-US" smtClean="0"/>
+              <a:rPr lang="en-US"/>
               <a:t>Click to edit Master text styles</a:t>
             </a:r>
           </a:p>
           <a:p>
             <a:pPr lvl="1"/>
             <a:r>
-              <a:rPr lang="en-US" smtClean="0"/>
+              <a:rPr lang="en-US"/>
               <a:t>Second level</a:t>
             </a:r>
           </a:p>
           <a:p>
             <a:pPr lvl="2"/>
             <a:r>
-              <a:rPr lang="en-US" smtClean="0"/>
+              <a:rPr lang="en-US"/>
               <a:t>Third level</a:t>
             </a:r>
           </a:p>
           <a:p>
             <a:pPr lvl="3"/>
             <a:r>
-              <a:rPr lang="en-US" smtClean="0"/>
+              <a:rPr lang="en-US"/>
               <a:t>Fourth level</a:t>
             </a:r>
           </a:p>
           <a:p>
             <a:pPr lvl="4"/>
             <a:r>
-              <a:rPr lang="en-US" smtClean="0"/>
+              <a:rPr lang="en-US"/>
               <a:t>Fifth level</a:t>
             </a:r>
-            <a:endParaRPr lang="en-US"/>
           </a:p>
         </p:txBody>
       </p:sp>
@@ -1314,38 +1319,37 @@
           <a:p>
             <a:pPr lvl="0"/>
             <a:r>
-              <a:rPr lang="en-US" smtClean="0"/>
+              <a:rPr lang="en-US"/>
               <a:t>Click to edit Master text styles</a:t>
             </a:r>
           </a:p>
           <a:p>
             <a:pPr lvl="1"/>
             <a:r>
-              <a:rPr lang="en-US" smtClean="0"/>
+              <a:rPr lang="en-US"/>
               <a:t>Second level</a:t>
             </a:r>
           </a:p>
           <a:p>
             <a:pPr lvl="2"/>
             <a:r>
-              <a:rPr lang="en-US" smtClean="0"/>
+              <a:rPr lang="en-US"/>
               <a:t>Third level</a:t>
             </a:r>
           </a:p>
           <a:p>
             <a:pPr lvl="3"/>
             <a:r>
-              <a:rPr lang="en-US" smtClean="0"/>
+              <a:rPr lang="en-US"/>
               <a:t>Fourth level</a:t>
             </a:r>
           </a:p>
           <a:p>
             <a:pPr lvl="4"/>
             <a:r>
-              <a:rPr lang="en-US" smtClean="0"/>
+              <a:rPr lang="en-US"/>
               <a:t>Fifth level</a:t>
             </a:r>
-            <a:endParaRPr lang="en-US"/>
           </a:p>
         </p:txBody>
       </p:sp>
@@ -1366,7 +1370,7 @@
           <a:p>
             <a:fld id="{5BCAD085-E8A6-8845-BD4E-CB4CCA059FC4}" type="datetimeFigureOut">
               <a:rPr lang="en-US" smtClean="0"/>
-              <a:t>1/27/13</a:t>
+              <a:t>6/22/2026</a:t>
             </a:fld>
             <a:endParaRPr lang="en-US"/>
           </a:p>
@@ -1408,7 +1412,7 @@
           <a:p>
             <a:fld id="{C1FF6DA9-008F-8B48-92A6-B652298478BF}" type="slidenum">
               <a:rPr lang="en-US" smtClean="0"/>
-              <a:t>‹#›</a:t>
+              <a:t>‹nº›</a:t>
             </a:fld>
             <a:endParaRPr lang="en-US"/>
           </a:p>
@@ -1464,10 +1468,9 @@
           </a:lstStyle>
           <a:p>
             <a:r>
-              <a:rPr lang="en-US" smtClean="0"/>
+              <a:rPr lang="en-US"/>
               <a:t>Click to edit Master title style</a:t>
             </a:r>
-            <a:endParaRPr lang="en-US"/>
           </a:p>
         </p:txBody>
       </p:sp>
@@ -1530,7 +1533,7 @@
           <a:p>
             <a:pPr lvl="0"/>
             <a:r>
-              <a:rPr lang="en-US" smtClean="0"/>
+              <a:rPr lang="en-US"/>
               <a:t>Click to edit Master text styles</a:t>
             </a:r>
           </a:p>
@@ -1586,38 +1589,37 @@
           <a:p>
             <a:pPr lvl="0"/>
             <a:r>
-              <a:rPr lang="en-US" smtClean="0"/>
+              <a:rPr lang="en-US"/>
               <a:t>Click to edit Master text styles</a:t>
             </a:r>
           </a:p>
           <a:p>
             <a:pPr lvl="1"/>
             <a:r>
-              <a:rPr lang="en-US" smtClean="0"/>
+              <a:rPr lang="en-US"/>
               <a:t>Second level</a:t>
             </a:r>
           </a:p>
           <a:p>
             <a:pPr lvl="2"/>
             <a:r>
-              <a:rPr lang="en-US" smtClean="0"/>
+              <a:rPr lang="en-US"/>
               <a:t>Third level</a:t>
             </a:r>
           </a:p>
           <a:p>
             <a:pPr lvl="3"/>
             <a:r>
-              <a:rPr lang="en-US" smtClean="0"/>
+              <a:rPr lang="en-US"/>
               <a:t>Fourth level</a:t>
             </a:r>
           </a:p>
           <a:p>
             <a:pPr lvl="4"/>
             <a:r>
-              <a:rPr lang="en-US" smtClean="0"/>
+              <a:rPr lang="en-US"/>
               <a:t>Fifth level</a:t>
             </a:r>
-            <a:endParaRPr lang="en-US"/>
           </a:p>
         </p:txBody>
       </p:sp>
@@ -1680,7 +1682,7 @@
           <a:p>
             <a:pPr lvl="0"/>
             <a:r>
-              <a:rPr lang="en-US" smtClean="0"/>
+              <a:rPr lang="en-US"/>
               <a:t>Click to edit Master text styles</a:t>
             </a:r>
           </a:p>
@@ -1736,38 +1738,37 @@
           <a:p>
             <a:pPr lvl="0"/>
             <a:r>
-              <a:rPr lang="en-US" smtClean="0"/>
+              <a:rPr lang="en-US"/>
               <a:t>Click to edit Master text styles</a:t>
             </a:r>
           </a:p>
           <a:p>
             <a:pPr lvl="1"/>
             <a:r>
-              <a:rPr lang="en-US" smtClean="0"/>
+              <a:rPr lang="en-US"/>
               <a:t>Second level</a:t>
             </a:r>
           </a:p>
           <a:p>
             <a:pPr lvl="2"/>
             <a:r>
-              <a:rPr lang="en-US" smtClean="0"/>
+              <a:rPr lang="en-US"/>
               <a:t>Third level</a:t>
             </a:r>
           </a:p>
           <a:p>
             <a:pPr lvl="3"/>
             <a:r>
-              <a:rPr lang="en-US" smtClean="0"/>
+              <a:rPr lang="en-US"/>
               <a:t>Fourth level</a:t>
             </a:r>
           </a:p>
           <a:p>
             <a:pPr lvl="4"/>
             <a:r>
-              <a:rPr lang="en-US" smtClean="0"/>
+              <a:rPr lang="en-US"/>
               <a:t>Fifth level</a:t>
             </a:r>
-            <a:endParaRPr lang="en-US"/>
           </a:p>
         </p:txBody>
       </p:sp>
@@ -1788,7 +1789,7 @@
           <a:p>
             <a:fld id="{5BCAD085-E8A6-8845-BD4E-CB4CCA059FC4}" type="datetimeFigureOut">
               <a:rPr lang="en-US" smtClean="0"/>
-              <a:t>1/27/13</a:t>
+              <a:t>6/22/2026</a:t>
             </a:fld>
             <a:endParaRPr lang="en-US"/>
           </a:p>
@@ -1830,7 +1831,7 @@
           <a:p>
             <a:fld id="{C1FF6DA9-008F-8B48-92A6-B652298478BF}" type="slidenum">
               <a:rPr lang="en-US" smtClean="0"/>
-              <a:t>‹#›</a:t>
+              <a:t>‹nº›</a:t>
             </a:fld>
             <a:endParaRPr lang="en-US"/>
           </a:p>
@@ -1882,10 +1883,9 @@
           <a:lstStyle/>
           <a:p>
             <a:r>
-              <a:rPr lang="en-US" smtClean="0"/>
+              <a:rPr lang="en-US"/>
               <a:t>Click to edit Master title style</a:t>
             </a:r>
-            <a:endParaRPr lang="en-US"/>
           </a:p>
         </p:txBody>
       </p:sp>
@@ -1906,7 +1906,7 @@
           <a:p>
             <a:fld id="{5BCAD085-E8A6-8845-BD4E-CB4CCA059FC4}" type="datetimeFigureOut">
               <a:rPr lang="en-US" smtClean="0"/>
-              <a:t>1/27/13</a:t>
+              <a:t>6/22/2026</a:t>
             </a:fld>
             <a:endParaRPr lang="en-US"/>
           </a:p>
@@ -1948,7 +1948,7 @@
           <a:p>
             <a:fld id="{C1FF6DA9-008F-8B48-92A6-B652298478BF}" type="slidenum">
               <a:rPr lang="en-US" smtClean="0"/>
-              <a:t>‹#›</a:t>
+              <a:t>‹nº›</a:t>
             </a:fld>
             <a:endParaRPr lang="en-US"/>
           </a:p>
@@ -2001,7 +2001,7 @@
           <a:p>
             <a:fld id="{5BCAD085-E8A6-8845-BD4E-CB4CCA059FC4}" type="datetimeFigureOut">
               <a:rPr lang="en-US" smtClean="0"/>
-              <a:t>1/27/13</a:t>
+              <a:t>6/22/2026</a:t>
             </a:fld>
             <a:endParaRPr lang="en-US"/>
           </a:p>
@@ -2043,7 +2043,7 @@
           <a:p>
             <a:fld id="{C1FF6DA9-008F-8B48-92A6-B652298478BF}" type="slidenum">
               <a:rPr lang="en-US" smtClean="0"/>
-              <a:t>‹#›</a:t>
+              <a:t>‹nº›</a:t>
             </a:fld>
             <a:endParaRPr lang="en-US"/>
           </a:p>
@@ -2104,10 +2104,9 @@
           </a:lstStyle>
           <a:p>
             <a:r>
-              <a:rPr lang="en-US" smtClean="0"/>
+              <a:rPr lang="en-US"/>
               <a:t>Click to edit Master title style</a:t>
             </a:r>
-            <a:endParaRPr lang="en-US"/>
           </a:p>
         </p:txBody>
       </p:sp>
@@ -2161,38 +2160,37 @@
           <a:p>
             <a:pPr lvl="0"/>
             <a:r>
-              <a:rPr lang="en-US" smtClean="0"/>
+              <a:rPr lang="en-US"/>
               <a:t>Click to edit Master text styles</a:t>
             </a:r>
           </a:p>
           <a:p>
             <a:pPr lvl="1"/>
             <a:r>
-              <a:rPr lang="en-US" smtClean="0"/>
+              <a:rPr lang="en-US"/>
               <a:t>Second level</a:t>
             </a:r>
           </a:p>
           <a:p>
             <a:pPr lvl="2"/>
             <a:r>
-              <a:rPr lang="en-US" smtClean="0"/>
+              <a:rPr lang="en-US"/>
               <a:t>Third level</a:t>
             </a:r>
           </a:p>
           <a:p>
             <a:pPr lvl="3"/>
             <a:r>
-              <a:rPr lang="en-US" smtClean="0"/>
+              <a:rPr lang="en-US"/>
               <a:t>Fourth level</a:t>
             </a:r>
           </a:p>
           <a:p>
             <a:pPr lvl="4"/>
             <a:r>
-              <a:rPr lang="en-US" smtClean="0"/>
+              <a:rPr lang="en-US"/>
               <a:t>Fifth level</a:t>
             </a:r>
-            <a:endParaRPr lang="en-US"/>
           </a:p>
         </p:txBody>
       </p:sp>
@@ -2255,7 +2253,7 @@
           <a:p>
             <a:pPr lvl="0"/>
             <a:r>
-              <a:rPr lang="en-US" smtClean="0"/>
+              <a:rPr lang="en-US"/>
               <a:t>Click to edit Master text styles</a:t>
             </a:r>
           </a:p>
@@ -2278,7 +2276,7 @@
           <a:p>
             <a:fld id="{5BCAD085-E8A6-8845-BD4E-CB4CCA059FC4}" type="datetimeFigureOut">
               <a:rPr lang="en-US" smtClean="0"/>
-              <a:t>1/27/13</a:t>
+              <a:t>6/22/2026</a:t>
             </a:fld>
             <a:endParaRPr lang="en-US"/>
           </a:p>
@@ -2320,7 +2318,7 @@
           <a:p>
             <a:fld id="{C1FF6DA9-008F-8B48-92A6-B652298478BF}" type="slidenum">
               <a:rPr lang="en-US" smtClean="0"/>
-              <a:t>‹#›</a:t>
+              <a:t>‹nº›</a:t>
             </a:fld>
             <a:endParaRPr lang="en-US"/>
           </a:p>
@@ -2381,10 +2379,9 @@
           </a:lstStyle>
           <a:p>
             <a:r>
-              <a:rPr lang="en-US" smtClean="0"/>
+              <a:rPr lang="en-US"/>
               <a:t>Click to edit Master title style</a:t>
             </a:r>
-            <a:endParaRPr lang="en-US"/>
           </a:p>
         </p:txBody>
       </p:sp>
@@ -2508,7 +2505,7 @@
           <a:p>
             <a:pPr lvl="0"/>
             <a:r>
-              <a:rPr lang="en-US" smtClean="0"/>
+              <a:rPr lang="en-US"/>
               <a:t>Click to edit Master text styles</a:t>
             </a:r>
           </a:p>
@@ -2531,7 +2528,7 @@
           <a:p>
             <a:fld id="{5BCAD085-E8A6-8845-BD4E-CB4CCA059FC4}" type="datetimeFigureOut">
               <a:rPr lang="en-US" smtClean="0"/>
-              <a:t>1/27/13</a:t>
+              <a:t>6/22/2026</a:t>
             </a:fld>
             <a:endParaRPr lang="en-US"/>
           </a:p>
@@ -2573,7 +2570,7 @@
           <a:p>
             <a:fld id="{C1FF6DA9-008F-8B48-92A6-B652298478BF}" type="slidenum">
               <a:rPr lang="en-US" smtClean="0"/>
-              <a:t>‹#›</a:t>
+              <a:t>‹nº›</a:t>
             </a:fld>
             <a:endParaRPr lang="en-US"/>
           </a:p>
@@ -2640,10 +2637,9 @@
           <a:lstStyle/>
           <a:p>
             <a:r>
-              <a:rPr lang="en-US" smtClean="0"/>
+              <a:rPr lang="en-US"/>
               <a:t>Click to edit Master title style</a:t>
             </a:r>
-            <a:endParaRPr lang="en-US"/>
           </a:p>
         </p:txBody>
       </p:sp>
@@ -2674,38 +2670,37 @@
           <a:p>
             <a:pPr lvl="0"/>
             <a:r>
-              <a:rPr lang="en-US" smtClean="0"/>
+              <a:rPr lang="en-US"/>
               <a:t>Click to edit Master text styles</a:t>
             </a:r>
           </a:p>
           <a:p>
             <a:pPr lvl="1"/>
             <a:r>
-              <a:rPr lang="en-US" smtClean="0"/>
+              <a:rPr lang="en-US"/>
               <a:t>Second level</a:t>
             </a:r>
           </a:p>
           <a:p>
             <a:pPr lvl="2"/>
             <a:r>
-              <a:rPr lang="en-US" smtClean="0"/>
+              <a:rPr lang="en-US"/>
               <a:t>Third level</a:t>
             </a:r>
           </a:p>
           <a:p>
             <a:pPr lvl="3"/>
             <a:r>
-              <a:rPr lang="en-US" smtClean="0"/>
+              <a:rPr lang="en-US"/>
               <a:t>Fourth level</a:t>
             </a:r>
           </a:p>
           <a:p>
             <a:pPr lvl="4"/>
             <a:r>
-              <a:rPr lang="en-US" smtClean="0"/>
+              <a:rPr lang="en-US"/>
               <a:t>Fifth level</a:t>
             </a:r>
-            <a:endParaRPr lang="en-US"/>
           </a:p>
         </p:txBody>
       </p:sp>
@@ -2744,7 +2739,7 @@
           <a:p>
             <a:fld id="{5BCAD085-E8A6-8845-BD4E-CB4CCA059FC4}" type="datetimeFigureOut">
               <a:rPr lang="en-US" smtClean="0"/>
-              <a:t>1/27/13</a:t>
+              <a:t>6/22/2026</a:t>
             </a:fld>
             <a:endParaRPr lang="en-US"/>
           </a:p>
@@ -2822,7 +2817,7 @@
           <a:p>
             <a:fld id="{C1FF6DA9-008F-8B48-92A6-B652298478BF}" type="slidenum">
               <a:rPr lang="en-US" smtClean="0"/>
-              <a:t>‹#›</a:t>
+              <a:t>‹nº›</a:t>
             </a:fld>
             <a:endParaRPr lang="en-US"/>
           </a:p>
@@ -3103,7 +3098,7 @@
 </file>
 
 <file path=ppt/slides/slide1.xml><?xml version="1.0" encoding="utf-8"?>
-<p:sld xmlns:a="http://schemas.openxmlformats.org/drawingml/2006/main" xmlns:p="http://schemas.openxmlformats.org/presentationml/2006/main" xmlns:r="http://schemas.openxmlformats.org/officeDocument/2006/relationships">
+<p:sld xmlns:a="http://schemas.openxmlformats.org/drawingml/2006/main" xmlns:r="http://schemas.openxmlformats.org/officeDocument/2006/relationships" xmlns:p="http://schemas.openxmlformats.org/presentationml/2006/main">
   <p:cSld>
     <p:spTree>
       <p:nvGrpSpPr>
@@ -3111,7 +3106,14 @@
         <p:cNvGrpSpPr/>
         <p:nvPr/>
       </p:nvGrpSpPr>
-      <p:grpSpPr/>
+      <p:grpSpPr>
+        <a:xfrm>
+          <a:off x="0" y="0"/>
+          <a:ext cx="0" cy="0"/>
+          <a:chOff x="0" y="0"/>
+          <a:chExt cx="0" cy="0"/>
+        </a:xfrm>
+      </p:grpSpPr>
       <p:sp>
         <p:nvSpPr>
           <p:cNvPr id="2" name="Rectangle 1"/>
@@ -3153,6 +3155,7 @@
           <a:lstStyle/>
           <a:p>
             <a:pPr algn="ctr"/>
+            <a:endParaRPr/>
           </a:p>
         </p:txBody>
       </p:sp>
@@ -3199,6 +3202,7 @@
           <a:lstStyle/>
           <a:p>
             <a:pPr algn="ctr"/>
+            <a:endParaRPr/>
           </a:p>
         </p:txBody>
       </p:sp>
@@ -3245,6 +3249,7 @@
           <a:lstStyle/>
           <a:p>
             <a:pPr algn="ctr"/>
+            <a:endParaRPr/>
           </a:p>
         </p:txBody>
       </p:sp>
@@ -3291,6 +3296,7 @@
           <a:lstStyle/>
           <a:p>
             <a:pPr algn="ctr"/>
+            <a:endParaRPr/>
           </a:p>
         </p:txBody>
       </p:sp>
@@ -3337,6 +3343,7 @@
           <a:lstStyle/>
           <a:p>
             <a:pPr algn="ctr"/>
+            <a:endParaRPr/>
           </a:p>
         </p:txBody>
       </p:sp>
@@ -3383,6 +3390,7 @@
           <a:lstStyle/>
           <a:p>
             <a:pPr algn="ctr"/>
+            <a:endParaRPr/>
           </a:p>
         </p:txBody>
       </p:sp>
@@ -3429,6 +3437,7 @@
           <a:lstStyle/>
           <a:p>
             <a:pPr algn="ctr"/>
+            <a:endParaRPr/>
           </a:p>
         </p:txBody>
       </p:sp>
@@ -3475,6 +3484,7 @@
           <a:lstStyle/>
           <a:p>
             <a:pPr algn="ctr"/>
+            <a:endParaRPr/>
           </a:p>
         </p:txBody>
       </p:sp>
@@ -3626,8 +3636,8 @@
         </p:nvSpPr>
         <p:spPr>
           <a:xfrm>
-            <a:off x="1645920" y="4700016"/>
-            <a:ext cx="9601200" cy="310896"/>
+            <a:off x="1645920" y="4713732"/>
+            <a:ext cx="9601200" cy="658368"/>
           </a:xfrm>
           <a:prstGeom prst="rect">
             <a:avLst/>
@@ -3640,50 +3650,69 @@
           </a:bodyPr>
           <a:lstStyle/>
           <a:p>
-            <a:pPr algn="l"/>
-            <a:r>
-              <a:rPr sz="1300" b="1" i="0">
+            <a:r>
+              <a:rPr lang="pt-BR" sz="1300" b="1" i="0" dirty="0">
                 <a:solidFill>
                   <a:srgbClr val="FFFFFF"/>
                 </a:solidFill>
                 <a:latin typeface="Calibri"/>
               </a:rPr>
-              <a:t>Arthur Real Sanchotene Ferreira · Caroline da Rocha de Lima · Giovani da Silva Cancherini</a:t>
-            </a:r>
-          </a:p>
-        </p:txBody>
-      </p:sp>
-      <p:sp>
-        <p:nvSpPr>
-          <p:cNvPr id="15" name="TextBox 14"/>
-          <p:cNvSpPr txBox="1"/>
-          <p:nvPr/>
-        </p:nvSpPr>
-        <p:spPr>
-          <a:xfrm>
-            <a:off x="1645920" y="4992624"/>
-            <a:ext cx="9601200" cy="310896"/>
-          </a:xfrm>
-          <a:prstGeom prst="rect">
-            <a:avLst/>
-          </a:prstGeom>
-          <a:noFill/>
-        </p:spPr>
-        <p:txBody>
-          <a:bodyPr wrap="square" lIns="0" tIns="0" rIns="0" bIns="0" anchor="t">
-            <a:noAutofit/>
-          </a:bodyPr>
-          <a:lstStyle/>
-          <a:p>
-            <a:pPr algn="l"/>
-            <a:r>
-              <a:rPr sz="1300" b="0" i="0">
-                <a:solidFill>
-                  <a:srgbClr val="9AA0AA"/>
-                </a:solidFill>
-                <a:latin typeface="Calibri"/>
-              </a:rPr>
-              <a:t>Leonardo Vargas Schilling · Osmar Sadi Nether Filho</a:t>
+              <a:t>Arthur Real </a:t>
+            </a:r>
+            <a:r>
+              <a:rPr lang="pt-BR" sz="1300" b="1" i="0" dirty="0" err="1">
+                <a:solidFill>
+                  <a:srgbClr val="FFFFFF"/>
+                </a:solidFill>
+                <a:latin typeface="Calibri"/>
+              </a:rPr>
+              <a:t>Sanchotene</a:t>
+            </a:r>
+            <a:r>
+              <a:rPr lang="pt-BR" sz="1300" b="1" i="0" dirty="0">
+                <a:solidFill>
+                  <a:srgbClr val="FFFFFF"/>
+                </a:solidFill>
+                <a:latin typeface="Calibri"/>
+              </a:rPr>
+              <a:t> Ferreira · Caroline da Rocha de Lima · Giovani da </a:t>
+            </a:r>
+            <a:r>
+              <a:rPr lang="pt-BR" sz="1300" b="1" dirty="0">
+                <a:solidFill>
+                  <a:srgbClr val="FFFFFF"/>
+                </a:solidFill>
+              </a:rPr>
+              <a:t>Silva Cancherini · </a:t>
+            </a:r>
+          </a:p>
+          <a:p>
+            <a:r>
+              <a:rPr lang="pt-BR" sz="1300" b="1" i="0" dirty="0">
+                <a:solidFill>
+                  <a:srgbClr val="FFFFFF"/>
+                </a:solidFill>
+                <a:latin typeface="Calibri"/>
+              </a:rPr>
+              <a:t>Leonardo Vargas Schilling · Osmar Sadi </a:t>
+            </a:r>
+            <a:r>
+              <a:rPr lang="pt-BR" sz="1300" b="1" i="0" dirty="0" err="1">
+                <a:solidFill>
+                  <a:srgbClr val="FFFFFF"/>
+                </a:solidFill>
+                <a:latin typeface="Calibri"/>
+              </a:rPr>
+              <a:t>Nether</a:t>
+            </a:r>
+            <a:r>
+              <a:rPr lang="pt-BR" sz="1300" b="1" i="0" dirty="0">
+                <a:solidFill>
+                  <a:srgbClr val="FFFFFF"/>
+                </a:solidFill>
+                <a:latin typeface="Calibri"/>
+              </a:rPr>
+              <a:t> Filho</a:t>
             </a:r>
           </a:p>
         </p:txBody>
@@ -3712,13 +3741,31 @@
           <a:p>
             <a:pPr algn="l"/>
             <a:r>
-              <a:rPr sz="1200" b="0" i="1">
+              <a:rPr sz="1200" b="0" i="1" dirty="0">
                 <a:solidFill>
                   <a:srgbClr val="9AA0AA"/>
                 </a:solidFill>
                 <a:latin typeface="Calibri"/>
               </a:rPr>
-              <a:t>Prof. Fernando Dotti · Porto Alegre, junho de 2026</a:t>
+              <a:t>Prof. Fernando Dotti · Porto Alegre, </a:t>
+            </a:r>
+            <a:r>
+              <a:rPr sz="1200" b="0" i="1" dirty="0" err="1">
+                <a:solidFill>
+                  <a:srgbClr val="9AA0AA"/>
+                </a:solidFill>
+                <a:latin typeface="Calibri"/>
+              </a:rPr>
+              <a:t>junho</a:t>
+            </a:r>
+            <a:r>
+              <a:rPr sz="1200" b="0" i="1" dirty="0">
+                <a:solidFill>
+                  <a:srgbClr val="9AA0AA"/>
+                </a:solidFill>
+                <a:latin typeface="Calibri"/>
+              </a:rPr>
+              <a:t> de 2026</a:t>
             </a:r>
           </a:p>
         </p:txBody>
@@ -3732,7 +3779,7 @@
 </file>
 
 <file path=ppt/slides/slide10.xml><?xml version="1.0" encoding="utf-8"?>
-<p:sld xmlns:a="http://schemas.openxmlformats.org/drawingml/2006/main" xmlns:p="http://schemas.openxmlformats.org/presentationml/2006/main" xmlns:r="http://schemas.openxmlformats.org/officeDocument/2006/relationships">
+<p:sld xmlns:a="http://schemas.openxmlformats.org/drawingml/2006/main" xmlns:r="http://schemas.openxmlformats.org/officeDocument/2006/relationships" xmlns:p="http://schemas.openxmlformats.org/presentationml/2006/main">
   <p:cSld>
     <p:spTree>
       <p:nvGrpSpPr>
@@ -3740,7 +3787,14 @@
         <p:cNvGrpSpPr/>
         <p:nvPr/>
       </p:nvGrpSpPr>
-      <p:grpSpPr/>
+      <p:grpSpPr>
+        <a:xfrm>
+          <a:off x="0" y="0"/>
+          <a:ext cx="0" cy="0"/>
+          <a:chOff x="0" y="0"/>
+          <a:chExt cx="0" cy="0"/>
+        </a:xfrm>
+      </p:grpSpPr>
       <p:sp>
         <p:nvSpPr>
           <p:cNvPr id="2" name="Rectangle 1"/>
@@ -3782,6 +3836,7 @@
           <a:lstStyle/>
           <a:p>
             <a:pPr algn="ctr"/>
+            <a:endParaRPr/>
           </a:p>
         </p:txBody>
       </p:sp>
@@ -3826,6 +3881,7 @@
           <a:lstStyle/>
           <a:p>
             <a:pPr algn="ctr"/>
+            <a:endParaRPr/>
           </a:p>
         </p:txBody>
       </p:sp>
@@ -3983,6 +4039,7 @@
           <a:lstStyle/>
           <a:p>
             <a:pPr algn="ctr"/>
+            <a:endParaRPr/>
           </a:p>
         </p:txBody>
       </p:sp>
@@ -4027,6 +4084,7 @@
           <a:lstStyle/>
           <a:p>
             <a:pPr algn="ctr"/>
+            <a:endParaRPr/>
           </a:p>
         </p:txBody>
       </p:sp>
@@ -4153,6 +4211,7 @@
           <a:lstStyle/>
           <a:p>
             <a:pPr algn="ctr"/>
+            <a:endParaRPr/>
           </a:p>
         </p:txBody>
       </p:sp>
@@ -4197,6 +4256,7 @@
           <a:lstStyle/>
           <a:p>
             <a:pPr algn="ctr"/>
+            <a:endParaRPr/>
           </a:p>
         </p:txBody>
       </p:sp>
@@ -4323,6 +4383,7 @@
           <a:lstStyle/>
           <a:p>
             <a:pPr algn="ctr"/>
+            <a:endParaRPr/>
           </a:p>
         </p:txBody>
       </p:sp>
@@ -4367,6 +4428,7 @@
           <a:lstStyle/>
           <a:p>
             <a:pPr algn="ctr"/>
+            <a:endParaRPr/>
           </a:p>
         </p:txBody>
       </p:sp>
@@ -4493,6 +4555,7 @@
           <a:lstStyle/>
           <a:p>
             <a:pPr algn="ctr"/>
+            <a:endParaRPr/>
           </a:p>
         </p:txBody>
       </p:sp>
@@ -4537,6 +4600,7 @@
           <a:lstStyle/>
           <a:p>
             <a:pPr algn="ctr"/>
+            <a:endParaRPr/>
           </a:p>
         </p:txBody>
       </p:sp>
@@ -4663,6 +4727,7 @@
           <a:lstStyle/>
           <a:p>
             <a:pPr algn="ctr"/>
+            <a:endParaRPr/>
           </a:p>
         </p:txBody>
       </p:sp>
@@ -4707,6 +4772,7 @@
           <a:lstStyle/>
           <a:p>
             <a:pPr algn="ctr"/>
+            <a:endParaRPr/>
           </a:p>
         </p:txBody>
       </p:sp>
@@ -4833,6 +4899,7 @@
           <a:lstStyle/>
           <a:p>
             <a:pPr algn="ctr"/>
+            <a:endParaRPr/>
           </a:p>
         </p:txBody>
       </p:sp>
@@ -4877,6 +4944,7 @@
           <a:lstStyle/>
           <a:p>
             <a:pPr algn="ctr"/>
+            <a:endParaRPr/>
           </a:p>
         </p:txBody>
       </p:sp>
@@ -4998,7 +5066,7 @@
 </file>
 
 <file path=ppt/slides/slide11.xml><?xml version="1.0" encoding="utf-8"?>
-<p:sld xmlns:a="http://schemas.openxmlformats.org/drawingml/2006/main" xmlns:p="http://schemas.openxmlformats.org/presentationml/2006/main" xmlns:r="http://schemas.openxmlformats.org/officeDocument/2006/relationships">
+<p:sld xmlns:a="http://schemas.openxmlformats.org/drawingml/2006/main" xmlns:r="http://schemas.openxmlformats.org/officeDocument/2006/relationships" xmlns:p="http://schemas.openxmlformats.org/presentationml/2006/main">
   <p:cSld>
     <p:spTree>
       <p:nvGrpSpPr>
@@ -5006,7 +5074,14 @@
         <p:cNvGrpSpPr/>
         <p:nvPr/>
       </p:nvGrpSpPr>
-      <p:grpSpPr/>
+      <p:grpSpPr>
+        <a:xfrm>
+          <a:off x="0" y="0"/>
+          <a:ext cx="0" cy="0"/>
+          <a:chOff x="0" y="0"/>
+          <a:chExt cx="0" cy="0"/>
+        </a:xfrm>
+      </p:grpSpPr>
       <p:sp>
         <p:nvSpPr>
           <p:cNvPr id="2" name="Rectangle 1"/>
@@ -5048,6 +5123,7 @@
           <a:lstStyle/>
           <a:p>
             <a:pPr algn="ctr"/>
+            <a:endParaRPr/>
           </a:p>
         </p:txBody>
       </p:sp>
@@ -5092,6 +5168,7 @@
           <a:lstStyle/>
           <a:p>
             <a:pPr algn="ctr"/>
+            <a:endParaRPr/>
           </a:p>
         </p:txBody>
       </p:sp>
@@ -5243,6 +5320,7 @@
           <a:lstStyle/>
           <a:p>
             <a:pPr algn="ctr"/>
+            <a:endParaRPr/>
           </a:p>
         </p:txBody>
       </p:sp>
@@ -5359,6 +5437,7 @@
           <a:lstStyle/>
           <a:p>
             <a:pPr algn="ctr"/>
+            <a:endParaRPr/>
           </a:p>
         </p:txBody>
       </p:sp>
@@ -5475,6 +5554,7 @@
           <a:lstStyle/>
           <a:p>
             <a:pPr algn="ctr"/>
+            <a:endParaRPr/>
           </a:p>
         </p:txBody>
       </p:sp>
@@ -5734,6 +5814,7 @@
           <a:lstStyle/>
           <a:p>
             <a:pPr algn="ctr"/>
+            <a:endParaRPr/>
           </a:p>
         </p:txBody>
       </p:sp>
@@ -5850,6 +5931,7 @@
           <a:lstStyle/>
           <a:p>
             <a:pPr algn="ctr"/>
+            <a:endParaRPr/>
           </a:p>
         </p:txBody>
       </p:sp>
@@ -5973,6 +6055,7 @@
           <a:lstStyle/>
           <a:p>
             <a:pPr algn="ctr"/>
+            <a:endParaRPr/>
           </a:p>
         </p:txBody>
       </p:sp>
@@ -6052,6 +6135,7 @@
           <a:lstStyle/>
           <a:p>
             <a:pPr algn="ctr"/>
+            <a:endParaRPr/>
           </a:p>
         </p:txBody>
       </p:sp>
@@ -6131,6 +6215,7 @@
           <a:lstStyle/>
           <a:p>
             <a:pPr algn="ctr"/>
+            <a:endParaRPr/>
           </a:p>
         </p:txBody>
       </p:sp>
@@ -6210,6 +6295,7 @@
           <a:lstStyle/>
           <a:p>
             <a:pPr algn="ctr"/>
+            <a:endParaRPr/>
           </a:p>
         </p:txBody>
       </p:sp>
@@ -6289,6 +6375,7 @@
           <a:lstStyle/>
           <a:p>
             <a:pPr algn="ctr"/>
+            <a:endParaRPr/>
           </a:p>
         </p:txBody>
       </p:sp>
@@ -6368,6 +6455,7 @@
           <a:lstStyle/>
           <a:p>
             <a:pPr algn="ctr"/>
+            <a:endParaRPr/>
           </a:p>
         </p:txBody>
       </p:sp>
@@ -6485,6 +6573,7 @@
           <a:lstStyle/>
           <a:p>
             <a:pPr algn="ctr"/>
+            <a:endParaRPr/>
           </a:p>
         </p:txBody>
       </p:sp>
@@ -6602,7 +6691,7 @@
 </file>
 
 <file path=ppt/slides/slide12.xml><?xml version="1.0" encoding="utf-8"?>
-<p:sld xmlns:a="http://schemas.openxmlformats.org/drawingml/2006/main" xmlns:p="http://schemas.openxmlformats.org/presentationml/2006/main" xmlns:r="http://schemas.openxmlformats.org/officeDocument/2006/relationships">
+<p:sld xmlns:a="http://schemas.openxmlformats.org/drawingml/2006/main" xmlns:r="http://schemas.openxmlformats.org/officeDocument/2006/relationships" xmlns:p="http://schemas.openxmlformats.org/presentationml/2006/main">
   <p:cSld>
     <p:spTree>
       <p:nvGrpSpPr>
@@ -6610,7 +6699,14 @@
         <p:cNvGrpSpPr/>
         <p:nvPr/>
       </p:nvGrpSpPr>
-      <p:grpSpPr/>
+      <p:grpSpPr>
+        <a:xfrm>
+          <a:off x="0" y="0"/>
+          <a:ext cx="0" cy="0"/>
+          <a:chOff x="0" y="0"/>
+          <a:chExt cx="0" cy="0"/>
+        </a:xfrm>
+      </p:grpSpPr>
       <p:sp>
         <p:nvSpPr>
           <p:cNvPr id="2" name="Rectangle 1"/>
@@ -6652,6 +6748,7 @@
           <a:lstStyle/>
           <a:p>
             <a:pPr algn="ctr"/>
+            <a:endParaRPr/>
           </a:p>
         </p:txBody>
       </p:sp>
@@ -6696,6 +6793,7 @@
           <a:lstStyle/>
           <a:p>
             <a:pPr algn="ctr"/>
+            <a:endParaRPr/>
           </a:p>
         </p:txBody>
       </p:sp>
@@ -6853,6 +6951,7 @@
           <a:lstStyle/>
           <a:p>
             <a:pPr algn="ctr"/>
+            <a:endParaRPr/>
           </a:p>
         </p:txBody>
       </p:sp>
@@ -6932,6 +7031,7 @@
           <a:lstStyle/>
           <a:p>
             <a:pPr algn="ctr"/>
+            <a:endParaRPr/>
           </a:p>
         </p:txBody>
       </p:sp>
@@ -7011,6 +7111,7 @@
           <a:lstStyle/>
           <a:p>
             <a:pPr algn="ctr"/>
+            <a:endParaRPr/>
           </a:p>
         </p:txBody>
       </p:sp>
@@ -7090,6 +7191,7 @@
           <a:lstStyle/>
           <a:p>
             <a:pPr algn="ctr"/>
+            <a:endParaRPr/>
           </a:p>
         </p:txBody>
       </p:sp>
@@ -7169,6 +7271,7 @@
           <a:lstStyle/>
           <a:p>
             <a:pPr algn="ctr"/>
+            <a:endParaRPr/>
           </a:p>
         </p:txBody>
       </p:sp>
@@ -7248,6 +7351,7 @@
           <a:lstStyle/>
           <a:p>
             <a:pPr algn="ctr"/>
+            <a:endParaRPr/>
           </a:p>
         </p:txBody>
       </p:sp>
@@ -7333,6 +7437,7 @@
           <a:lstStyle/>
           <a:p>
             <a:pPr algn="ctr"/>
+            <a:endParaRPr/>
           </a:p>
         </p:txBody>
       </p:sp>
@@ -7455,6 +7560,7 @@
           <a:lstStyle/>
           <a:p>
             <a:pPr algn="ctr"/>
+            <a:endParaRPr/>
           </a:p>
         </p:txBody>
       </p:sp>
@@ -7534,6 +7640,7 @@
           <a:lstStyle/>
           <a:p>
             <a:pPr algn="ctr"/>
+            <a:endParaRPr/>
           </a:p>
         </p:txBody>
       </p:sp>
@@ -7699,6 +7806,7 @@
           <a:lstStyle/>
           <a:p>
             <a:pPr algn="ctr"/>
+            <a:endParaRPr/>
           </a:p>
         </p:txBody>
       </p:sp>
@@ -7816,7 +7924,7 @@
 </file>
 
 <file path=ppt/slides/slide13.xml><?xml version="1.0" encoding="utf-8"?>
-<p:sld xmlns:a="http://schemas.openxmlformats.org/drawingml/2006/main" xmlns:p="http://schemas.openxmlformats.org/presentationml/2006/main" xmlns:r="http://schemas.openxmlformats.org/officeDocument/2006/relationships">
+<p:sld xmlns:a="http://schemas.openxmlformats.org/drawingml/2006/main" xmlns:r="http://schemas.openxmlformats.org/officeDocument/2006/relationships" xmlns:p="http://schemas.openxmlformats.org/presentationml/2006/main">
   <p:cSld>
     <p:spTree>
       <p:nvGrpSpPr>
@@ -7824,7 +7932,14 @@
         <p:cNvGrpSpPr/>
         <p:nvPr/>
       </p:nvGrpSpPr>
-      <p:grpSpPr/>
+      <p:grpSpPr>
+        <a:xfrm>
+          <a:off x="0" y="0"/>
+          <a:ext cx="0" cy="0"/>
+          <a:chOff x="0" y="0"/>
+          <a:chExt cx="0" cy="0"/>
+        </a:xfrm>
+      </p:grpSpPr>
       <p:sp>
         <p:nvSpPr>
           <p:cNvPr id="2" name="Rectangle 1"/>
@@ -7866,6 +7981,7 @@
           <a:lstStyle/>
           <a:p>
             <a:pPr algn="ctr"/>
+            <a:endParaRPr/>
           </a:p>
         </p:txBody>
       </p:sp>
@@ -7910,6 +8026,7 @@
           <a:lstStyle/>
           <a:p>
             <a:pPr algn="ctr"/>
+            <a:endParaRPr/>
           </a:p>
         </p:txBody>
       </p:sp>
@@ -8102,6 +8219,7 @@
           <a:lstStyle/>
           <a:p>
             <a:pPr algn="ctr"/>
+            <a:endParaRPr/>
           </a:p>
         </p:txBody>
       </p:sp>
@@ -8146,6 +8264,7 @@
           <a:lstStyle/>
           <a:p>
             <a:pPr algn="ctr"/>
+            <a:endParaRPr/>
           </a:p>
         </p:txBody>
       </p:sp>
@@ -8272,6 +8391,7 @@
           <a:lstStyle/>
           <a:p>
             <a:pPr algn="ctr"/>
+            <a:endParaRPr/>
           </a:p>
         </p:txBody>
       </p:sp>
@@ -8316,6 +8436,7 @@
           <a:lstStyle/>
           <a:p>
             <a:pPr algn="ctr"/>
+            <a:endParaRPr/>
           </a:p>
         </p:txBody>
       </p:sp>
@@ -8442,6 +8563,7 @@
           <a:lstStyle/>
           <a:p>
             <a:pPr algn="ctr"/>
+            <a:endParaRPr/>
           </a:p>
         </p:txBody>
       </p:sp>
@@ -8486,6 +8608,7 @@
           <a:lstStyle/>
           <a:p>
             <a:pPr algn="ctr"/>
+            <a:endParaRPr/>
           </a:p>
         </p:txBody>
       </p:sp>
@@ -8612,6 +8735,7 @@
           <a:lstStyle/>
           <a:p>
             <a:pPr algn="ctr"/>
+            <a:endParaRPr/>
           </a:p>
         </p:txBody>
       </p:sp>
@@ -8656,6 +8780,7 @@
           <a:lstStyle/>
           <a:p>
             <a:pPr algn="ctr"/>
+            <a:endParaRPr/>
           </a:p>
         </p:txBody>
       </p:sp>
@@ -8817,6 +8942,7 @@
           <a:lstStyle/>
           <a:p>
             <a:pPr algn="ctr"/>
+            <a:endParaRPr/>
           </a:p>
         </p:txBody>
       </p:sp>
@@ -8861,6 +8987,7 @@
           <a:lstStyle/>
           <a:p>
             <a:pPr algn="ctr"/>
+            <a:endParaRPr/>
           </a:p>
         </p:txBody>
       </p:sp>
@@ -8987,6 +9114,7 @@
           <a:lstStyle/>
           <a:p>
             <a:pPr algn="ctr"/>
+            <a:endParaRPr/>
           </a:p>
         </p:txBody>
       </p:sp>
@@ -9031,6 +9159,7 @@
           <a:lstStyle/>
           <a:p>
             <a:pPr algn="ctr"/>
+            <a:endParaRPr/>
           </a:p>
         </p:txBody>
       </p:sp>
@@ -9187,7 +9316,7 @@
 </file>
 
 <file path=ppt/slides/slide14.xml><?xml version="1.0" encoding="utf-8"?>
-<p:sld xmlns:a="http://schemas.openxmlformats.org/drawingml/2006/main" xmlns:p="http://schemas.openxmlformats.org/presentationml/2006/main" xmlns:r="http://schemas.openxmlformats.org/officeDocument/2006/relationships">
+<p:sld xmlns:a="http://schemas.openxmlformats.org/drawingml/2006/main" xmlns:r="http://schemas.openxmlformats.org/officeDocument/2006/relationships" xmlns:p="http://schemas.openxmlformats.org/presentationml/2006/main">
   <p:cSld>
     <p:spTree>
       <p:nvGrpSpPr>
@@ -9195,7 +9324,14 @@
         <p:cNvGrpSpPr/>
         <p:nvPr/>
       </p:nvGrpSpPr>
-      <p:grpSpPr/>
+      <p:grpSpPr>
+        <a:xfrm>
+          <a:off x="0" y="0"/>
+          <a:ext cx="0" cy="0"/>
+          <a:chOff x="0" y="0"/>
+          <a:chExt cx="0" cy="0"/>
+        </a:xfrm>
+      </p:grpSpPr>
       <p:sp>
         <p:nvSpPr>
           <p:cNvPr id="2" name="Rectangle 1"/>
@@ -9237,6 +9373,7 @@
           <a:lstStyle/>
           <a:p>
             <a:pPr algn="ctr"/>
+            <a:endParaRPr/>
           </a:p>
         </p:txBody>
       </p:sp>
@@ -9281,6 +9418,7 @@
           <a:lstStyle/>
           <a:p>
             <a:pPr algn="ctr"/>
+            <a:endParaRPr/>
           </a:p>
         </p:txBody>
       </p:sp>
@@ -9438,6 +9576,7 @@
           <a:lstStyle/>
           <a:p>
             <a:pPr algn="ctr"/>
+            <a:endParaRPr/>
           </a:p>
         </p:txBody>
       </p:sp>
@@ -9556,6 +9695,7 @@
           <a:lstStyle/>
           <a:p>
             <a:pPr algn="ctr"/>
+            <a:endParaRPr/>
           </a:p>
         </p:txBody>
       </p:sp>
@@ -9706,6 +9846,7 @@
           <a:lstStyle/>
           <a:p>
             <a:pPr algn="ctr"/>
+            <a:endParaRPr/>
           </a:p>
         </p:txBody>
       </p:sp>
@@ -9785,6 +9926,7 @@
           <a:lstStyle/>
           <a:p>
             <a:pPr algn="ctr"/>
+            <a:endParaRPr/>
           </a:p>
         </p:txBody>
       </p:sp>
@@ -9864,6 +10006,7 @@
           <a:lstStyle/>
           <a:p>
             <a:pPr algn="ctr"/>
+            <a:endParaRPr/>
           </a:p>
         </p:txBody>
       </p:sp>
@@ -9951,6 +10094,7 @@
           <a:lstStyle/>
           <a:p>
             <a:pPr algn="ctr"/>
+            <a:endParaRPr/>
           </a:p>
         </p:txBody>
       </p:sp>
@@ -10069,6 +10213,7 @@
           <a:lstStyle/>
           <a:p>
             <a:pPr algn="ctr"/>
+            <a:endParaRPr/>
           </a:p>
         </p:txBody>
       </p:sp>
@@ -10293,7 +10438,7 @@
 </file>
 
 <file path=ppt/slides/slide15.xml><?xml version="1.0" encoding="utf-8"?>
-<p:sld xmlns:a="http://schemas.openxmlformats.org/drawingml/2006/main" xmlns:p="http://schemas.openxmlformats.org/presentationml/2006/main" xmlns:r="http://schemas.openxmlformats.org/officeDocument/2006/relationships">
+<p:sld xmlns:a="http://schemas.openxmlformats.org/drawingml/2006/main" xmlns:r="http://schemas.openxmlformats.org/officeDocument/2006/relationships" xmlns:p="http://schemas.openxmlformats.org/presentationml/2006/main">
   <p:cSld>
     <p:spTree>
       <p:nvGrpSpPr>
@@ -10301,7 +10446,14 @@
         <p:cNvGrpSpPr/>
         <p:nvPr/>
       </p:nvGrpSpPr>
-      <p:grpSpPr/>
+      <p:grpSpPr>
+        <a:xfrm>
+          <a:off x="0" y="0"/>
+          <a:ext cx="0" cy="0"/>
+          <a:chOff x="0" y="0"/>
+          <a:chExt cx="0" cy="0"/>
+        </a:xfrm>
+      </p:grpSpPr>
       <p:sp>
         <p:nvSpPr>
           <p:cNvPr id="2" name="Rectangle 1"/>
@@ -10343,6 +10495,7 @@
           <a:lstStyle/>
           <a:p>
             <a:pPr algn="ctr"/>
+            <a:endParaRPr/>
           </a:p>
         </p:txBody>
       </p:sp>
@@ -10387,6 +10540,7 @@
           <a:lstStyle/>
           <a:p>
             <a:pPr algn="ctr"/>
+            <a:endParaRPr/>
           </a:p>
         </p:txBody>
       </p:sp>
@@ -10544,6 +10698,7 @@
           <a:lstStyle/>
           <a:p>
             <a:pPr algn="ctr"/>
+            <a:endParaRPr/>
           </a:p>
         </p:txBody>
       </p:sp>
@@ -10662,6 +10817,7 @@
           <a:lstStyle/>
           <a:p>
             <a:pPr algn="ctr"/>
+            <a:endParaRPr/>
           </a:p>
         </p:txBody>
       </p:sp>
@@ -10777,6 +10933,7 @@
           <a:lstStyle/>
           <a:p>
             <a:pPr algn="ctr"/>
+            <a:endParaRPr/>
           </a:p>
         </p:txBody>
       </p:sp>
@@ -10856,6 +11013,7 @@
           <a:lstStyle/>
           <a:p>
             <a:pPr algn="ctr"/>
+            <a:endParaRPr/>
           </a:p>
         </p:txBody>
       </p:sp>
@@ -10935,6 +11093,7 @@
           <a:lstStyle/>
           <a:p>
             <a:pPr algn="ctr"/>
+            <a:endParaRPr/>
           </a:p>
         </p:txBody>
       </p:sp>
@@ -11014,6 +11173,7 @@
           <a:lstStyle/>
           <a:p>
             <a:pPr algn="ctr"/>
+            <a:endParaRPr/>
           </a:p>
         </p:txBody>
       </p:sp>
@@ -11101,6 +11261,7 @@
           <a:lstStyle/>
           <a:p>
             <a:pPr algn="ctr"/>
+            <a:endParaRPr/>
           </a:p>
         </p:txBody>
       </p:sp>
@@ -11219,6 +11380,7 @@
           <a:lstStyle/>
           <a:p>
             <a:pPr algn="ctr"/>
+            <a:endParaRPr/>
           </a:p>
         </p:txBody>
       </p:sp>
@@ -11298,6 +11460,7 @@
           <a:lstStyle/>
           <a:p>
             <a:pPr algn="ctr"/>
+            <a:endParaRPr/>
           </a:p>
         </p:txBody>
       </p:sp>
@@ -11377,6 +11540,7 @@
           <a:lstStyle/>
           <a:p>
             <a:pPr algn="ctr"/>
+            <a:endParaRPr/>
           </a:p>
         </p:txBody>
       </p:sp>
@@ -11491,6 +11655,7 @@
           <a:lstStyle/>
           <a:p>
             <a:pPr algn="ctr"/>
+            <a:endParaRPr/>
           </a:p>
         </p:txBody>
       </p:sp>
@@ -11570,6 +11735,7 @@
           <a:lstStyle/>
           <a:p>
             <a:pPr algn="ctr"/>
+            <a:endParaRPr/>
           </a:p>
         </p:txBody>
       </p:sp>
@@ -11652,7 +11818,7 @@
 </file>
 
 <file path=ppt/slides/slide16.xml><?xml version="1.0" encoding="utf-8"?>
-<p:sld xmlns:a="http://schemas.openxmlformats.org/drawingml/2006/main" xmlns:p="http://schemas.openxmlformats.org/presentationml/2006/main" xmlns:r="http://schemas.openxmlformats.org/officeDocument/2006/relationships">
+<p:sld xmlns:a="http://schemas.openxmlformats.org/drawingml/2006/main" xmlns:r="http://schemas.openxmlformats.org/officeDocument/2006/relationships" xmlns:p="http://schemas.openxmlformats.org/presentationml/2006/main">
   <p:cSld>
     <p:spTree>
       <p:nvGrpSpPr>
@@ -11660,7 +11826,14 @@
         <p:cNvGrpSpPr/>
         <p:nvPr/>
       </p:nvGrpSpPr>
-      <p:grpSpPr/>
+      <p:grpSpPr>
+        <a:xfrm>
+          <a:off x="0" y="0"/>
+          <a:ext cx="0" cy="0"/>
+          <a:chOff x="0" y="0"/>
+          <a:chExt cx="0" cy="0"/>
+        </a:xfrm>
+      </p:grpSpPr>
       <p:sp>
         <p:nvSpPr>
           <p:cNvPr id="2" name="Rectangle 1"/>
@@ -11702,6 +11875,7 @@
           <a:lstStyle/>
           <a:p>
             <a:pPr algn="ctr"/>
+            <a:endParaRPr/>
           </a:p>
         </p:txBody>
       </p:sp>
@@ -11746,6 +11920,7 @@
           <a:lstStyle/>
           <a:p>
             <a:pPr algn="ctr"/>
+            <a:endParaRPr/>
           </a:p>
         </p:txBody>
       </p:sp>
@@ -11938,6 +12113,7 @@
           <a:lstStyle/>
           <a:p>
             <a:pPr algn="ctr"/>
+            <a:endParaRPr/>
           </a:p>
         </p:txBody>
       </p:sp>
@@ -12080,6 +12256,7 @@
           <a:lstStyle/>
           <a:p>
             <a:pPr algn="ctr"/>
+            <a:endParaRPr/>
           </a:p>
         </p:txBody>
       </p:sp>
@@ -12159,6 +12336,7 @@
           <a:lstStyle/>
           <a:p>
             <a:pPr algn="ctr"/>
+            <a:endParaRPr/>
           </a:p>
         </p:txBody>
       </p:sp>
@@ -12351,7 +12529,7 @@
 </file>
 
 <file path=ppt/slides/slide17.xml><?xml version="1.0" encoding="utf-8"?>
-<p:sld xmlns:a="http://schemas.openxmlformats.org/drawingml/2006/main" xmlns:p="http://schemas.openxmlformats.org/presentationml/2006/main" xmlns:r="http://schemas.openxmlformats.org/officeDocument/2006/relationships">
+<p:sld xmlns:a="http://schemas.openxmlformats.org/drawingml/2006/main" xmlns:r="http://schemas.openxmlformats.org/officeDocument/2006/relationships" xmlns:p="http://schemas.openxmlformats.org/presentationml/2006/main">
   <p:cSld>
     <p:spTree>
       <p:nvGrpSpPr>
@@ -12359,7 +12537,14 @@
         <p:cNvGrpSpPr/>
         <p:nvPr/>
       </p:nvGrpSpPr>
-      <p:grpSpPr/>
+      <p:grpSpPr>
+        <a:xfrm>
+          <a:off x="0" y="0"/>
+          <a:ext cx="0" cy="0"/>
+          <a:chOff x="0" y="0"/>
+          <a:chExt cx="0" cy="0"/>
+        </a:xfrm>
+      </p:grpSpPr>
       <p:sp>
         <p:nvSpPr>
           <p:cNvPr id="2" name="Rectangle 1"/>
@@ -12401,6 +12586,7 @@
           <a:lstStyle/>
           <a:p>
             <a:pPr algn="ctr"/>
+            <a:endParaRPr/>
           </a:p>
         </p:txBody>
       </p:sp>
@@ -12445,6 +12631,7 @@
           <a:lstStyle/>
           <a:p>
             <a:pPr algn="ctr"/>
+            <a:endParaRPr/>
           </a:p>
         </p:txBody>
       </p:sp>
@@ -12572,16 +12759,46 @@
                 <a:tableStyleId>{5C22544A-7EE6-4342-B048-85BDC9FD1C3A}</a:tableStyleId>
               </a:tblPr>
               <a:tblGrid>
-                <a:gridCol w="2181758"/>
-                <a:gridCol w="1636318"/>
-                <a:gridCol w="1636318"/>
-                <a:gridCol w="1963582"/>
-                <a:gridCol w="3490813"/>
+                <a:gridCol w="2181758">
+                  <a:extLst>
+                    <a:ext uri="{9D8B030D-6E8A-4147-A177-3AD203B41FA5}">
+                      <a16:colId xmlns:a16="http://schemas.microsoft.com/office/drawing/2014/main" val="20000"/>
+                    </a:ext>
+                  </a:extLst>
+                </a:gridCol>
+                <a:gridCol w="1636318">
+                  <a:extLst>
+                    <a:ext uri="{9D8B030D-6E8A-4147-A177-3AD203B41FA5}">
+                      <a16:colId xmlns:a16="http://schemas.microsoft.com/office/drawing/2014/main" val="20001"/>
+                    </a:ext>
+                  </a:extLst>
+                </a:gridCol>
+                <a:gridCol w="1636318">
+                  <a:extLst>
+                    <a:ext uri="{9D8B030D-6E8A-4147-A177-3AD203B41FA5}">
+                      <a16:colId xmlns:a16="http://schemas.microsoft.com/office/drawing/2014/main" val="20002"/>
+                    </a:ext>
+                  </a:extLst>
+                </a:gridCol>
+                <a:gridCol w="1963582">
+                  <a:extLst>
+                    <a:ext uri="{9D8B030D-6E8A-4147-A177-3AD203B41FA5}">
+                      <a16:colId xmlns:a16="http://schemas.microsoft.com/office/drawing/2014/main" val="20003"/>
+                    </a:ext>
+                  </a:extLst>
+                </a:gridCol>
+                <a:gridCol w="3490813">
+                  <a:extLst>
+                    <a:ext uri="{9D8B030D-6E8A-4147-A177-3AD203B41FA5}">
+                      <a16:colId xmlns:a16="http://schemas.microsoft.com/office/drawing/2014/main" val="20004"/>
+                    </a:ext>
+                  </a:extLst>
+                </a:gridCol>
               </a:tblGrid>
               <a:tr h="438912">
                 <a:tc>
                   <a:txBody>
-                    <a:bodyPr wrap="square"/>
+                    <a:bodyPr/>
                     <a:lstStyle/>
                     <a:p>
                       <a:r>
@@ -12603,7 +12820,7 @@
                 </a:tc>
                 <a:tc>
                   <a:txBody>
-                    <a:bodyPr wrap="square"/>
+                    <a:bodyPr/>
                     <a:lstStyle/>
                     <a:p>
                       <a:r>
@@ -12625,7 +12842,7 @@
                 </a:tc>
                 <a:tc>
                   <a:txBody>
-                    <a:bodyPr wrap="square"/>
+                    <a:bodyPr/>
                     <a:lstStyle/>
                     <a:p>
                       <a:r>
@@ -12647,7 +12864,7 @@
                 </a:tc>
                 <a:tc>
                   <a:txBody>
-                    <a:bodyPr wrap="square"/>
+                    <a:bodyPr/>
                     <a:lstStyle/>
                     <a:p>
                       <a:r>
@@ -12669,7 +12886,7 @@
                 </a:tc>
                 <a:tc>
                   <a:txBody>
-                    <a:bodyPr wrap="square"/>
+                    <a:bodyPr/>
                     <a:lstStyle/>
                     <a:p>
                       <a:r>
@@ -12689,11 +12906,16 @@
                     </a:solidFill>
                   </a:tcPr>
                 </a:tc>
+                <a:extLst>
+                  <a:ext uri="{0D108BD9-81ED-4DB2-BD59-A6C34878D82A}">
+                    <a16:rowId xmlns:a16="http://schemas.microsoft.com/office/drawing/2014/main" val="10000"/>
+                  </a:ext>
+                </a:extLst>
               </a:tr>
               <a:tr h="457200">
                 <a:tc>
                   <a:txBody>
-                    <a:bodyPr wrap="square"/>
+                    <a:bodyPr/>
                     <a:lstStyle/>
                     <a:p>
                       <a:r>
@@ -12715,7 +12937,7 @@
                 </a:tc>
                 <a:tc>
                   <a:txBody>
-                    <a:bodyPr wrap="square"/>
+                    <a:bodyPr/>
                     <a:lstStyle/>
                     <a:p>
                       <a:r>
@@ -12737,7 +12959,7 @@
                 </a:tc>
                 <a:tc>
                   <a:txBody>
-                    <a:bodyPr wrap="square"/>
+                    <a:bodyPr/>
                     <a:lstStyle/>
                     <a:p>
                       <a:r>
@@ -12759,7 +12981,7 @@
                 </a:tc>
                 <a:tc>
                   <a:txBody>
-                    <a:bodyPr wrap="square"/>
+                    <a:bodyPr/>
                     <a:lstStyle/>
                     <a:p>
                       <a:r>
@@ -12781,7 +13003,7 @@
                 </a:tc>
                 <a:tc>
                   <a:txBody>
-                    <a:bodyPr wrap="square"/>
+                    <a:bodyPr/>
                     <a:lstStyle/>
                     <a:p>
                       <a:r>
@@ -12801,11 +13023,16 @@
                     </a:solidFill>
                   </a:tcPr>
                 </a:tc>
+                <a:extLst>
+                  <a:ext uri="{0D108BD9-81ED-4DB2-BD59-A6C34878D82A}">
+                    <a16:rowId xmlns:a16="http://schemas.microsoft.com/office/drawing/2014/main" val="10001"/>
+                  </a:ext>
+                </a:extLst>
               </a:tr>
               <a:tr h="457200">
                 <a:tc>
                   <a:txBody>
-                    <a:bodyPr wrap="square"/>
+                    <a:bodyPr/>
                     <a:lstStyle/>
                     <a:p>
                       <a:r>
@@ -12827,7 +13054,7 @@
                 </a:tc>
                 <a:tc>
                   <a:txBody>
-                    <a:bodyPr wrap="square"/>
+                    <a:bodyPr/>
                     <a:lstStyle/>
                     <a:p>
                       <a:r>
@@ -12849,7 +13076,7 @@
                 </a:tc>
                 <a:tc>
                   <a:txBody>
-                    <a:bodyPr wrap="square"/>
+                    <a:bodyPr/>
                     <a:lstStyle/>
                     <a:p>
                       <a:r>
@@ -12871,7 +13098,7 @@
                 </a:tc>
                 <a:tc>
                   <a:txBody>
-                    <a:bodyPr wrap="square"/>
+                    <a:bodyPr/>
                     <a:lstStyle/>
                     <a:p>
                       <a:r>
@@ -12893,7 +13120,7 @@
                 </a:tc>
                 <a:tc>
                   <a:txBody>
-                    <a:bodyPr wrap="square"/>
+                    <a:bodyPr/>
                     <a:lstStyle/>
                     <a:p>
                       <a:r>
@@ -12913,11 +13140,16 @@
                     </a:solidFill>
                   </a:tcPr>
                 </a:tc>
+                <a:extLst>
+                  <a:ext uri="{0D108BD9-81ED-4DB2-BD59-A6C34878D82A}">
+                    <a16:rowId xmlns:a16="http://schemas.microsoft.com/office/drawing/2014/main" val="10002"/>
+                  </a:ext>
+                </a:extLst>
               </a:tr>
               <a:tr h="457200">
                 <a:tc>
                   <a:txBody>
-                    <a:bodyPr wrap="square"/>
+                    <a:bodyPr/>
                     <a:lstStyle/>
                     <a:p>
                       <a:r>
@@ -12939,7 +13171,7 @@
                 </a:tc>
                 <a:tc>
                   <a:txBody>
-                    <a:bodyPr wrap="square"/>
+                    <a:bodyPr/>
                     <a:lstStyle/>
                     <a:p>
                       <a:r>
@@ -12961,7 +13193,7 @@
                 </a:tc>
                 <a:tc>
                   <a:txBody>
-                    <a:bodyPr wrap="square"/>
+                    <a:bodyPr/>
                     <a:lstStyle/>
                     <a:p>
                       <a:r>
@@ -12983,7 +13215,7 @@
                 </a:tc>
                 <a:tc>
                   <a:txBody>
-                    <a:bodyPr wrap="square"/>
+                    <a:bodyPr/>
                     <a:lstStyle/>
                     <a:p>
                       <a:r>
@@ -13005,7 +13237,7 @@
                 </a:tc>
                 <a:tc>
                   <a:txBody>
-                    <a:bodyPr wrap="square"/>
+                    <a:bodyPr/>
                     <a:lstStyle/>
                     <a:p>
                       <a:r>
@@ -13025,11 +13257,16 @@
                     </a:solidFill>
                   </a:tcPr>
                 </a:tc>
+                <a:extLst>
+                  <a:ext uri="{0D108BD9-81ED-4DB2-BD59-A6C34878D82A}">
+                    <a16:rowId xmlns:a16="http://schemas.microsoft.com/office/drawing/2014/main" val="10003"/>
+                  </a:ext>
+                </a:extLst>
               </a:tr>
               <a:tr h="457200">
                 <a:tc>
                   <a:txBody>
-                    <a:bodyPr wrap="square"/>
+                    <a:bodyPr/>
                     <a:lstStyle/>
                     <a:p>
                       <a:r>
@@ -13051,7 +13288,7 @@
                 </a:tc>
                 <a:tc>
                   <a:txBody>
-                    <a:bodyPr wrap="square"/>
+                    <a:bodyPr/>
                     <a:lstStyle/>
                     <a:p>
                       <a:r>
@@ -13073,7 +13310,7 @@
                 </a:tc>
                 <a:tc>
                   <a:txBody>
-                    <a:bodyPr wrap="square"/>
+                    <a:bodyPr/>
                     <a:lstStyle/>
                     <a:p>
                       <a:r>
@@ -13095,7 +13332,7 @@
                 </a:tc>
                 <a:tc>
                   <a:txBody>
-                    <a:bodyPr wrap="square"/>
+                    <a:bodyPr/>
                     <a:lstStyle/>
                     <a:p>
                       <a:r>
@@ -13117,7 +13354,7 @@
                 </a:tc>
                 <a:tc>
                   <a:txBody>
-                    <a:bodyPr wrap="square"/>
+                    <a:bodyPr/>
                     <a:lstStyle/>
                     <a:p>
                       <a:r>
@@ -13137,11 +13374,16 @@
                     </a:solidFill>
                   </a:tcPr>
                 </a:tc>
+                <a:extLst>
+                  <a:ext uri="{0D108BD9-81ED-4DB2-BD59-A6C34878D82A}">
+                    <a16:rowId xmlns:a16="http://schemas.microsoft.com/office/drawing/2014/main" val="10004"/>
+                  </a:ext>
+                </a:extLst>
               </a:tr>
               <a:tr h="457200">
                 <a:tc>
                   <a:txBody>
-                    <a:bodyPr wrap="square"/>
+                    <a:bodyPr/>
                     <a:lstStyle/>
                     <a:p>
                       <a:r>
@@ -13163,7 +13405,7 @@
                 </a:tc>
                 <a:tc>
                   <a:txBody>
-                    <a:bodyPr wrap="square"/>
+                    <a:bodyPr/>
                     <a:lstStyle/>
                     <a:p>
                       <a:r>
@@ -13185,7 +13427,7 @@
                 </a:tc>
                 <a:tc>
                   <a:txBody>
-                    <a:bodyPr wrap="square"/>
+                    <a:bodyPr/>
                     <a:lstStyle/>
                     <a:p>
                       <a:r>
@@ -13207,7 +13449,7 @@
                 </a:tc>
                 <a:tc>
                   <a:txBody>
-                    <a:bodyPr wrap="square"/>
+                    <a:bodyPr/>
                     <a:lstStyle/>
                     <a:p>
                       <a:r>
@@ -13229,7 +13471,7 @@
                 </a:tc>
                 <a:tc>
                   <a:txBody>
-                    <a:bodyPr wrap="square"/>
+                    <a:bodyPr/>
                     <a:lstStyle/>
                     <a:p>
                       <a:r>
@@ -13249,6 +13491,11 @@
                     </a:solidFill>
                   </a:tcPr>
                 </a:tc>
+                <a:extLst>
+                  <a:ext uri="{0D108BD9-81ED-4DB2-BD59-A6C34878D82A}">
+                    <a16:rowId xmlns:a16="http://schemas.microsoft.com/office/drawing/2014/main" val="10005"/>
+                  </a:ext>
+                </a:extLst>
               </a:tr>
             </a:tbl>
           </a:graphicData>
@@ -13333,7 +13580,7 @@
 </file>
 
 <file path=ppt/slides/slide18.xml><?xml version="1.0" encoding="utf-8"?>
-<p:sld xmlns:a="http://schemas.openxmlformats.org/drawingml/2006/main" xmlns:p="http://schemas.openxmlformats.org/presentationml/2006/main" xmlns:r="http://schemas.openxmlformats.org/officeDocument/2006/relationships">
+<p:sld xmlns:a="http://schemas.openxmlformats.org/drawingml/2006/main" xmlns:r="http://schemas.openxmlformats.org/officeDocument/2006/relationships" xmlns:p="http://schemas.openxmlformats.org/presentationml/2006/main">
   <p:cSld>
     <p:spTree>
       <p:nvGrpSpPr>
@@ -13341,7 +13588,14 @@
         <p:cNvGrpSpPr/>
         <p:nvPr/>
       </p:nvGrpSpPr>
-      <p:grpSpPr/>
+      <p:grpSpPr>
+        <a:xfrm>
+          <a:off x="0" y="0"/>
+          <a:ext cx="0" cy="0"/>
+          <a:chOff x="0" y="0"/>
+          <a:chExt cx="0" cy="0"/>
+        </a:xfrm>
+      </p:grpSpPr>
       <p:sp>
         <p:nvSpPr>
           <p:cNvPr id="2" name="Rectangle 1"/>
@@ -13383,6 +13637,7 @@
           <a:lstStyle/>
           <a:p>
             <a:pPr algn="ctr"/>
+            <a:endParaRPr/>
           </a:p>
         </p:txBody>
       </p:sp>
@@ -13427,6 +13682,7 @@
           <a:lstStyle/>
           <a:p>
             <a:pPr algn="ctr"/>
+            <a:endParaRPr/>
           </a:p>
         </p:txBody>
       </p:sp>
@@ -13578,6 +13834,7 @@
           <a:lstStyle/>
           <a:p>
             <a:pPr algn="ctr"/>
+            <a:endParaRPr/>
           </a:p>
         </p:txBody>
       </p:sp>
@@ -13695,6 +13952,7 @@
           <a:lstStyle/>
           <a:p>
             <a:pPr algn="ctr"/>
+            <a:endParaRPr/>
           </a:p>
         </p:txBody>
       </p:sp>
@@ -13812,6 +14070,7 @@
           <a:lstStyle/>
           <a:p>
             <a:pPr algn="ctr"/>
+            <a:endParaRPr/>
           </a:p>
         </p:txBody>
       </p:sp>
@@ -13929,6 +14188,7 @@
           <a:lstStyle/>
           <a:p>
             <a:pPr algn="ctr"/>
+            <a:endParaRPr/>
           </a:p>
         </p:txBody>
       </p:sp>
@@ -14046,6 +14306,7 @@
           <a:lstStyle/>
           <a:p>
             <a:pPr algn="ctr"/>
+            <a:endParaRPr/>
           </a:p>
         </p:txBody>
       </p:sp>
@@ -14163,6 +14424,7 @@
           <a:lstStyle/>
           <a:p>
             <a:pPr algn="ctr"/>
+            <a:endParaRPr/>
           </a:p>
         </p:txBody>
       </p:sp>
@@ -14277,6 +14539,7 @@
           <a:lstStyle/>
           <a:p>
             <a:pPr algn="ctr"/>
+            <a:endParaRPr/>
           </a:p>
         </p:txBody>
       </p:sp>
@@ -14368,6 +14631,7 @@
           <a:lstStyle/>
           <a:p>
             <a:pPr algn="ctr"/>
+            <a:endParaRPr/>
           </a:p>
         </p:txBody>
       </p:sp>
@@ -14486,6 +14750,7 @@
           <a:lstStyle/>
           <a:p>
             <a:pPr algn="ctr"/>
+            <a:endParaRPr/>
           </a:p>
         </p:txBody>
       </p:sp>
@@ -14581,7 +14846,7 @@
 </file>
 
 <file path=ppt/slides/slide19.xml><?xml version="1.0" encoding="utf-8"?>
-<p:sld xmlns:a="http://schemas.openxmlformats.org/drawingml/2006/main" xmlns:p="http://schemas.openxmlformats.org/presentationml/2006/main" xmlns:r="http://schemas.openxmlformats.org/officeDocument/2006/relationships">
+<p:sld xmlns:a="http://schemas.openxmlformats.org/drawingml/2006/main" xmlns:r="http://schemas.openxmlformats.org/officeDocument/2006/relationships" xmlns:p="http://schemas.openxmlformats.org/presentationml/2006/main">
   <p:cSld>
     <p:spTree>
       <p:nvGrpSpPr>
@@ -14589,7 +14854,14 @@
         <p:cNvGrpSpPr/>
         <p:nvPr/>
       </p:nvGrpSpPr>
-      <p:grpSpPr/>
+      <p:grpSpPr>
+        <a:xfrm>
+          <a:off x="0" y="0"/>
+          <a:ext cx="0" cy="0"/>
+          <a:chOff x="0" y="0"/>
+          <a:chExt cx="0" cy="0"/>
+        </a:xfrm>
+      </p:grpSpPr>
       <p:sp>
         <p:nvSpPr>
           <p:cNvPr id="2" name="Rectangle 1"/>
@@ -14631,6 +14903,7 @@
           <a:lstStyle/>
           <a:p>
             <a:pPr algn="ctr"/>
+            <a:endParaRPr/>
           </a:p>
         </p:txBody>
       </p:sp>
@@ -14675,6 +14948,7 @@
           <a:lstStyle/>
           <a:p>
             <a:pPr algn="ctr"/>
+            <a:endParaRPr/>
           </a:p>
         </p:txBody>
       </p:sp>
@@ -14832,6 +15106,7 @@
           <a:lstStyle/>
           <a:p>
             <a:pPr algn="ctr"/>
+            <a:endParaRPr/>
           </a:p>
         </p:txBody>
       </p:sp>
@@ -14913,6 +15188,7 @@
           <a:lstStyle/>
           <a:p>
             <a:pPr algn="ctr"/>
+            <a:endParaRPr/>
           </a:p>
         </p:txBody>
       </p:sp>
@@ -14994,6 +15270,7 @@
           <a:lstStyle/>
           <a:p>
             <a:pPr algn="ctr"/>
+            <a:endParaRPr/>
           </a:p>
         </p:txBody>
       </p:sp>
@@ -15075,6 +15352,7 @@
           <a:lstStyle/>
           <a:p>
             <a:pPr algn="ctr"/>
+            <a:endParaRPr/>
           </a:p>
         </p:txBody>
       </p:sp>
@@ -15156,6 +15434,7 @@
           <a:lstStyle/>
           <a:p>
             <a:pPr algn="ctr"/>
+            <a:endParaRPr/>
           </a:p>
         </p:txBody>
       </p:sp>
@@ -15278,6 +15557,7 @@
           <a:lstStyle/>
           <a:p>
             <a:pPr algn="ctr"/>
+            <a:endParaRPr/>
           </a:p>
         </p:txBody>
       </p:sp>
@@ -15359,6 +15639,7 @@
           <a:lstStyle/>
           <a:p>
             <a:pPr algn="ctr"/>
+            <a:endParaRPr/>
           </a:p>
         </p:txBody>
       </p:sp>
@@ -15475,6 +15756,7 @@
           <a:lstStyle/>
           <a:p>
             <a:pPr algn="ctr"/>
+            <a:endParaRPr/>
           </a:p>
         </p:txBody>
       </p:sp>
@@ -15597,6 +15879,7 @@
           <a:lstStyle/>
           <a:p>
             <a:pPr algn="ctr"/>
+            <a:endParaRPr/>
           </a:p>
         </p:txBody>
       </p:sp>
@@ -15772,6 +16055,7 @@
           <a:lstStyle/>
           <a:p>
             <a:pPr algn="ctr"/>
+            <a:endParaRPr/>
           </a:p>
         </p:txBody>
       </p:sp>
@@ -15923,6 +16207,7 @@
           <a:lstStyle/>
           <a:p>
             <a:pPr algn="ctr"/>
+            <a:endParaRPr/>
           </a:p>
         </p:txBody>
       </p:sp>
@@ -16046,6 +16331,7 @@
           <a:lstStyle/>
           <a:p>
             <a:pPr algn="ctr"/>
+            <a:endParaRPr/>
           </a:p>
         </p:txBody>
       </p:sp>
@@ -16350,7 +16636,7 @@
 </file>
 
 <file path=ppt/slides/slide2.xml><?xml version="1.0" encoding="utf-8"?>
-<p:sld xmlns:a="http://schemas.openxmlformats.org/drawingml/2006/main" xmlns:p="http://schemas.openxmlformats.org/presentationml/2006/main" xmlns:r="http://schemas.openxmlformats.org/officeDocument/2006/relationships">
+<p:sld xmlns:a="http://schemas.openxmlformats.org/drawingml/2006/main" xmlns:r="http://schemas.openxmlformats.org/officeDocument/2006/relationships" xmlns:p="http://schemas.openxmlformats.org/presentationml/2006/main">
   <p:cSld>
     <p:spTree>
       <p:nvGrpSpPr>
@@ -16358,7 +16644,14 @@
         <p:cNvGrpSpPr/>
         <p:nvPr/>
       </p:nvGrpSpPr>
-      <p:grpSpPr/>
+      <p:grpSpPr>
+        <a:xfrm>
+          <a:off x="0" y="0"/>
+          <a:ext cx="0" cy="0"/>
+          <a:chOff x="0" y="0"/>
+          <a:chExt cx="0" cy="0"/>
+        </a:xfrm>
+      </p:grpSpPr>
       <p:sp>
         <p:nvSpPr>
           <p:cNvPr id="2" name="Rectangle 1"/>
@@ -16400,6 +16693,7 @@
           <a:lstStyle/>
           <a:p>
             <a:pPr algn="ctr"/>
+            <a:endParaRPr/>
           </a:p>
         </p:txBody>
       </p:sp>
@@ -16514,6 +16808,7 @@
           <a:lstStyle/>
           <a:p>
             <a:pPr algn="ctr"/>
+            <a:endParaRPr/>
           </a:p>
         </p:txBody>
       </p:sp>
@@ -16601,6 +16896,7 @@
           <a:lstStyle/>
           <a:p>
             <a:pPr algn="ctr"/>
+            <a:endParaRPr/>
           </a:p>
         </p:txBody>
       </p:sp>
@@ -16680,6 +16976,7 @@
           <a:lstStyle/>
           <a:p>
             <a:pPr algn="ctr"/>
+            <a:endParaRPr/>
           </a:p>
         </p:txBody>
       </p:sp>
@@ -16767,6 +17064,7 @@
           <a:lstStyle/>
           <a:p>
             <a:pPr algn="ctr"/>
+            <a:endParaRPr/>
           </a:p>
         </p:txBody>
       </p:sp>
@@ -16846,6 +17144,7 @@
           <a:lstStyle/>
           <a:p>
             <a:pPr algn="ctr"/>
+            <a:endParaRPr/>
           </a:p>
         </p:txBody>
       </p:sp>
@@ -16933,6 +17232,7 @@
           <a:lstStyle/>
           <a:p>
             <a:pPr algn="ctr"/>
+            <a:endParaRPr/>
           </a:p>
         </p:txBody>
       </p:sp>
@@ -17012,6 +17312,7 @@
           <a:lstStyle/>
           <a:p>
             <a:pPr algn="ctr"/>
+            <a:endParaRPr/>
           </a:p>
         </p:txBody>
       </p:sp>
@@ -17099,6 +17400,7 @@
           <a:lstStyle/>
           <a:p>
             <a:pPr algn="ctr"/>
+            <a:endParaRPr/>
           </a:p>
         </p:txBody>
       </p:sp>
@@ -17178,6 +17480,7 @@
           <a:lstStyle/>
           <a:p>
             <a:pPr algn="ctr"/>
+            <a:endParaRPr/>
           </a:p>
         </p:txBody>
       </p:sp>
@@ -17265,6 +17568,7 @@
           <a:lstStyle/>
           <a:p>
             <a:pPr algn="ctr"/>
+            <a:endParaRPr/>
           </a:p>
         </p:txBody>
       </p:sp>
@@ -17344,6 +17648,7 @@
           <a:lstStyle/>
           <a:p>
             <a:pPr algn="ctr"/>
+            <a:endParaRPr/>
           </a:p>
         </p:txBody>
       </p:sp>
@@ -17431,6 +17736,7 @@
           <a:lstStyle/>
           <a:p>
             <a:pPr algn="ctr"/>
+            <a:endParaRPr/>
           </a:p>
         </p:txBody>
       </p:sp>
@@ -17510,6 +17816,7 @@
           <a:lstStyle/>
           <a:p>
             <a:pPr algn="ctr"/>
+            <a:endParaRPr/>
           </a:p>
         </p:txBody>
       </p:sp>
@@ -17597,6 +17904,7 @@
           <a:lstStyle/>
           <a:p>
             <a:pPr algn="ctr"/>
+            <a:endParaRPr/>
           </a:p>
         </p:txBody>
       </p:sp>
@@ -17679,7 +17987,7 @@
 </file>
 
 <file path=ppt/slides/slide20.xml><?xml version="1.0" encoding="utf-8"?>
-<p:sld xmlns:a="http://schemas.openxmlformats.org/drawingml/2006/main" xmlns:p="http://schemas.openxmlformats.org/presentationml/2006/main" xmlns:r="http://schemas.openxmlformats.org/officeDocument/2006/relationships">
+<p:sld xmlns:a="http://schemas.openxmlformats.org/drawingml/2006/main" xmlns:r="http://schemas.openxmlformats.org/officeDocument/2006/relationships" xmlns:p="http://schemas.openxmlformats.org/presentationml/2006/main">
   <p:cSld>
     <p:spTree>
       <p:nvGrpSpPr>
@@ -17687,7 +17995,14 @@
         <p:cNvGrpSpPr/>
         <p:nvPr/>
       </p:nvGrpSpPr>
-      <p:grpSpPr/>
+      <p:grpSpPr>
+        <a:xfrm>
+          <a:off x="0" y="0"/>
+          <a:ext cx="0" cy="0"/>
+          <a:chOff x="0" y="0"/>
+          <a:chExt cx="0" cy="0"/>
+        </a:xfrm>
+      </p:grpSpPr>
       <p:sp>
         <p:nvSpPr>
           <p:cNvPr id="2" name="Rectangle 1"/>
@@ -17729,6 +18044,7 @@
           <a:lstStyle/>
           <a:p>
             <a:pPr algn="ctr"/>
+            <a:endParaRPr/>
           </a:p>
         </p:txBody>
       </p:sp>
@@ -17773,6 +18089,7 @@
           <a:lstStyle/>
           <a:p>
             <a:pPr algn="ctr"/>
+            <a:endParaRPr/>
           </a:p>
         </p:txBody>
       </p:sp>
@@ -17930,6 +18247,7 @@
           <a:lstStyle/>
           <a:p>
             <a:pPr algn="ctr"/>
+            <a:endParaRPr/>
           </a:p>
         </p:txBody>
       </p:sp>
@@ -18143,6 +18461,7 @@
           <a:lstStyle/>
           <a:p>
             <a:pPr algn="ctr"/>
+            <a:endParaRPr/>
           </a:p>
         </p:txBody>
       </p:sp>
@@ -18356,6 +18675,7 @@
           <a:lstStyle/>
           <a:p>
             <a:pPr algn="ctr"/>
+            <a:endParaRPr/>
           </a:p>
         </p:txBody>
       </p:sp>
@@ -18569,6 +18889,7 @@
           <a:lstStyle/>
           <a:p>
             <a:pPr algn="ctr"/>
+            <a:endParaRPr/>
           </a:p>
         </p:txBody>
       </p:sp>
@@ -18746,6 +19067,7 @@
           <a:lstStyle/>
           <a:p>
             <a:pPr algn="ctr"/>
+            <a:endParaRPr/>
           </a:p>
         </p:txBody>
       </p:sp>
@@ -18867,7 +19189,7 @@
 </file>
 
 <file path=ppt/slides/slide21.xml><?xml version="1.0" encoding="utf-8"?>
-<p:sld xmlns:a="http://schemas.openxmlformats.org/drawingml/2006/main" xmlns:p="http://schemas.openxmlformats.org/presentationml/2006/main" xmlns:r="http://schemas.openxmlformats.org/officeDocument/2006/relationships">
+<p:sld xmlns:a="http://schemas.openxmlformats.org/drawingml/2006/main" xmlns:r="http://schemas.openxmlformats.org/officeDocument/2006/relationships" xmlns:p="http://schemas.openxmlformats.org/presentationml/2006/main">
   <p:cSld>
     <p:spTree>
       <p:nvGrpSpPr>
@@ -18875,7 +19197,14 @@
         <p:cNvGrpSpPr/>
         <p:nvPr/>
       </p:nvGrpSpPr>
-      <p:grpSpPr/>
+      <p:grpSpPr>
+        <a:xfrm>
+          <a:off x="0" y="0"/>
+          <a:ext cx="0" cy="0"/>
+          <a:chOff x="0" y="0"/>
+          <a:chExt cx="0" cy="0"/>
+        </a:xfrm>
+      </p:grpSpPr>
       <p:sp>
         <p:nvSpPr>
           <p:cNvPr id="2" name="Rectangle 1"/>
@@ -18917,6 +19246,7 @@
           <a:lstStyle/>
           <a:p>
             <a:pPr algn="ctr"/>
+            <a:endParaRPr/>
           </a:p>
         </p:txBody>
       </p:sp>
@@ -18961,6 +19291,7 @@
           <a:lstStyle/>
           <a:p>
             <a:pPr algn="ctr"/>
+            <a:endParaRPr/>
           </a:p>
         </p:txBody>
       </p:sp>
@@ -19118,6 +19449,7 @@
           <a:lstStyle/>
           <a:p>
             <a:pPr algn="ctr"/>
+            <a:endParaRPr/>
           </a:p>
         </p:txBody>
       </p:sp>
@@ -19197,6 +19529,7 @@
           <a:lstStyle/>
           <a:p>
             <a:pPr algn="ctr"/>
+            <a:endParaRPr/>
           </a:p>
         </p:txBody>
       </p:sp>
@@ -19276,6 +19609,7 @@
           <a:lstStyle/>
           <a:p>
             <a:pPr algn="ctr"/>
+            <a:endParaRPr/>
           </a:p>
         </p:txBody>
       </p:sp>
@@ -19355,6 +19689,7 @@
           <a:lstStyle/>
           <a:p>
             <a:pPr algn="ctr"/>
+            <a:endParaRPr/>
           </a:p>
         </p:txBody>
       </p:sp>
@@ -19442,6 +19777,7 @@
           <a:lstStyle/>
           <a:p>
             <a:pPr algn="ctr"/>
+            <a:endParaRPr/>
           </a:p>
         </p:txBody>
       </p:sp>
@@ -19521,6 +19857,7 @@
           <a:lstStyle/>
           <a:p>
             <a:pPr algn="ctr"/>
+            <a:endParaRPr/>
           </a:p>
         </p:txBody>
       </p:sp>
@@ -19716,6 +20053,7 @@
           <a:lstStyle/>
           <a:p>
             <a:pPr algn="ctr"/>
+            <a:endParaRPr/>
           </a:p>
         </p:txBody>
       </p:sp>
@@ -19795,6 +20133,7 @@
           <a:lstStyle/>
           <a:p>
             <a:pPr algn="ctr"/>
+            <a:endParaRPr/>
           </a:p>
         </p:txBody>
       </p:sp>
@@ -19874,6 +20213,7 @@
           <a:lstStyle/>
           <a:p>
             <a:pPr algn="ctr"/>
+            <a:endParaRPr/>
           </a:p>
         </p:txBody>
       </p:sp>
@@ -19953,6 +20293,7 @@
           <a:lstStyle/>
           <a:p>
             <a:pPr algn="ctr"/>
+            <a:endParaRPr/>
           </a:p>
         </p:txBody>
       </p:sp>
@@ -20035,7 +20376,7 @@
 </file>
 
 <file path=ppt/slides/slide22.xml><?xml version="1.0" encoding="utf-8"?>
-<p:sld xmlns:a="http://schemas.openxmlformats.org/drawingml/2006/main" xmlns:p="http://schemas.openxmlformats.org/presentationml/2006/main" xmlns:r="http://schemas.openxmlformats.org/officeDocument/2006/relationships">
+<p:sld xmlns:a="http://schemas.openxmlformats.org/drawingml/2006/main" xmlns:r="http://schemas.openxmlformats.org/officeDocument/2006/relationships" xmlns:p="http://schemas.openxmlformats.org/presentationml/2006/main">
   <p:cSld>
     <p:spTree>
       <p:nvGrpSpPr>
@@ -20043,7 +20384,14 @@
         <p:cNvGrpSpPr/>
         <p:nvPr/>
       </p:nvGrpSpPr>
-      <p:grpSpPr/>
+      <p:grpSpPr>
+        <a:xfrm>
+          <a:off x="0" y="0"/>
+          <a:ext cx="0" cy="0"/>
+          <a:chOff x="0" y="0"/>
+          <a:chExt cx="0" cy="0"/>
+        </a:xfrm>
+      </p:grpSpPr>
       <p:sp>
         <p:nvSpPr>
           <p:cNvPr id="2" name="Rectangle 1"/>
@@ -20085,6 +20433,7 @@
           <a:lstStyle/>
           <a:p>
             <a:pPr algn="ctr"/>
+            <a:endParaRPr/>
           </a:p>
         </p:txBody>
       </p:sp>
@@ -20129,6 +20478,7 @@
           <a:lstStyle/>
           <a:p>
             <a:pPr algn="ctr"/>
+            <a:endParaRPr/>
           </a:p>
         </p:txBody>
       </p:sp>
@@ -20280,6 +20630,7 @@
           <a:lstStyle/>
           <a:p>
             <a:pPr algn="ctr"/>
+            <a:endParaRPr/>
           </a:p>
         </p:txBody>
       </p:sp>
@@ -20432,6 +20783,7 @@
           <a:lstStyle/>
           <a:p>
             <a:pPr algn="ctr"/>
+            <a:endParaRPr/>
           </a:p>
         </p:txBody>
       </p:sp>
@@ -20584,6 +20936,7 @@
           <a:lstStyle/>
           <a:p>
             <a:pPr algn="ctr"/>
+            <a:endParaRPr/>
           </a:p>
         </p:txBody>
       </p:sp>
@@ -20736,6 +21089,7 @@
           <a:lstStyle/>
           <a:p>
             <a:pPr algn="ctr"/>
+            <a:endParaRPr/>
           </a:p>
         </p:txBody>
       </p:sp>
@@ -20888,6 +21242,7 @@
           <a:lstStyle/>
           <a:p>
             <a:pPr algn="ctr"/>
+            <a:endParaRPr/>
           </a:p>
         </p:txBody>
       </p:sp>
@@ -21040,6 +21395,7 @@
           <a:lstStyle/>
           <a:p>
             <a:pPr algn="ctr"/>
+            <a:endParaRPr/>
           </a:p>
         </p:txBody>
       </p:sp>
@@ -21156,6 +21512,7 @@
           <a:lstStyle/>
           <a:p>
             <a:pPr algn="ctr"/>
+            <a:endParaRPr/>
           </a:p>
         </p:txBody>
       </p:sp>
@@ -21273,6 +21630,7 @@
           <a:lstStyle/>
           <a:p>
             <a:pPr algn="ctr"/>
+            <a:endParaRPr/>
           </a:p>
         </p:txBody>
       </p:sp>
@@ -21390,6 +21748,7 @@
           <a:lstStyle/>
           <a:p>
             <a:pPr algn="ctr"/>
+            <a:endParaRPr/>
           </a:p>
         </p:txBody>
       </p:sp>
@@ -21507,6 +21866,7 @@
           <a:lstStyle/>
           <a:p>
             <a:pPr algn="ctr"/>
+            <a:endParaRPr/>
           </a:p>
         </p:txBody>
       </p:sp>
@@ -21624,6 +21984,7 @@
           <a:lstStyle/>
           <a:p>
             <a:pPr algn="ctr"/>
+            <a:endParaRPr/>
           </a:p>
         </p:txBody>
       </p:sp>
@@ -21711,6 +22072,7 @@
           <a:lstStyle/>
           <a:p>
             <a:pPr algn="ctr"/>
+            <a:endParaRPr/>
           </a:p>
         </p:txBody>
       </p:sp>
@@ -21790,6 +22152,7 @@
           <a:lstStyle/>
           <a:p>
             <a:pPr algn="ctr"/>
+            <a:endParaRPr/>
           </a:p>
         </p:txBody>
       </p:sp>
@@ -21869,6 +22232,7 @@
           <a:lstStyle/>
           <a:p>
             <a:pPr algn="ctr"/>
+            <a:endParaRPr/>
           </a:p>
         </p:txBody>
       </p:sp>
@@ -21948,6 +22312,7 @@
           <a:lstStyle/>
           <a:p>
             <a:pPr algn="ctr"/>
+            <a:endParaRPr/>
           </a:p>
         </p:txBody>
       </p:sp>
@@ -22027,6 +22392,7 @@
           <a:lstStyle/>
           <a:p>
             <a:pPr algn="ctr"/>
+            <a:endParaRPr/>
           </a:p>
         </p:txBody>
       </p:sp>
@@ -22106,6 +22472,7 @@
           <a:lstStyle/>
           <a:p>
             <a:pPr algn="ctr"/>
+            <a:endParaRPr/>
           </a:p>
         </p:txBody>
       </p:sp>
@@ -22187,6 +22554,7 @@
           <a:lstStyle/>
           <a:p>
             <a:pPr algn="ctr"/>
+            <a:endParaRPr/>
           </a:p>
         </p:txBody>
       </p:sp>
@@ -22343,7 +22711,7 @@
 </file>
 
 <file path=ppt/slides/slide23.xml><?xml version="1.0" encoding="utf-8"?>
-<p:sld xmlns:a="http://schemas.openxmlformats.org/drawingml/2006/main" xmlns:p="http://schemas.openxmlformats.org/presentationml/2006/main" xmlns:r="http://schemas.openxmlformats.org/officeDocument/2006/relationships">
+<p:sld xmlns:a="http://schemas.openxmlformats.org/drawingml/2006/main" xmlns:r="http://schemas.openxmlformats.org/officeDocument/2006/relationships" xmlns:p="http://schemas.openxmlformats.org/presentationml/2006/main">
   <p:cSld>
     <p:spTree>
       <p:nvGrpSpPr>
@@ -22351,7 +22719,14 @@
         <p:cNvGrpSpPr/>
         <p:nvPr/>
       </p:nvGrpSpPr>
-      <p:grpSpPr/>
+      <p:grpSpPr>
+        <a:xfrm>
+          <a:off x="0" y="0"/>
+          <a:ext cx="0" cy="0"/>
+          <a:chOff x="0" y="0"/>
+          <a:chExt cx="0" cy="0"/>
+        </a:xfrm>
+      </p:grpSpPr>
       <p:sp>
         <p:nvSpPr>
           <p:cNvPr id="2" name="Rectangle 1"/>
@@ -22393,6 +22768,7 @@
           <a:lstStyle/>
           <a:p>
             <a:pPr algn="ctr"/>
+            <a:endParaRPr/>
           </a:p>
         </p:txBody>
       </p:sp>
@@ -22437,6 +22813,7 @@
           <a:lstStyle/>
           <a:p>
             <a:pPr algn="ctr"/>
+            <a:endParaRPr/>
           </a:p>
         </p:txBody>
       </p:sp>
@@ -22594,6 +22971,7 @@
           <a:lstStyle/>
           <a:p>
             <a:pPr algn="ctr"/>
+            <a:endParaRPr/>
           </a:p>
         </p:txBody>
       </p:sp>
@@ -22781,6 +23159,7 @@
           <a:lstStyle/>
           <a:p>
             <a:pPr algn="ctr"/>
+            <a:endParaRPr/>
           </a:p>
         </p:txBody>
       </p:sp>
@@ -22903,6 +23282,7 @@
           <a:lstStyle/>
           <a:p>
             <a:pPr algn="ctr"/>
+            <a:endParaRPr/>
           </a:p>
         </p:txBody>
       </p:sp>
@@ -23090,6 +23470,7 @@
           <a:lstStyle/>
           <a:p>
             <a:pPr algn="ctr"/>
+            <a:endParaRPr/>
           </a:p>
         </p:txBody>
       </p:sp>
@@ -23212,6 +23593,7 @@
           <a:lstStyle/>
           <a:p>
             <a:pPr algn="ctr"/>
+            <a:endParaRPr/>
           </a:p>
         </p:txBody>
       </p:sp>
@@ -23399,6 +23781,7 @@
           <a:lstStyle/>
           <a:p>
             <a:pPr algn="ctr"/>
+            <a:endParaRPr/>
           </a:p>
         </p:txBody>
       </p:sp>
@@ -23521,6 +23904,7 @@
           <a:lstStyle/>
           <a:p>
             <a:pPr algn="ctr"/>
+            <a:endParaRPr/>
           </a:p>
         </p:txBody>
       </p:sp>
@@ -23708,6 +24092,7 @@
           <a:lstStyle/>
           <a:p>
             <a:pPr algn="ctr"/>
+            <a:endParaRPr/>
           </a:p>
         </p:txBody>
       </p:sp>
@@ -23825,7 +24210,7 @@
 </file>
 
 <file path=ppt/slides/slide24.xml><?xml version="1.0" encoding="utf-8"?>
-<p:sld xmlns:a="http://schemas.openxmlformats.org/drawingml/2006/main" xmlns:p="http://schemas.openxmlformats.org/presentationml/2006/main" xmlns:r="http://schemas.openxmlformats.org/officeDocument/2006/relationships">
+<p:sld xmlns:a="http://schemas.openxmlformats.org/drawingml/2006/main" xmlns:r="http://schemas.openxmlformats.org/officeDocument/2006/relationships" xmlns:p="http://schemas.openxmlformats.org/presentationml/2006/main">
   <p:cSld>
     <p:spTree>
       <p:nvGrpSpPr>
@@ -23833,7 +24218,14 @@
         <p:cNvGrpSpPr/>
         <p:nvPr/>
       </p:nvGrpSpPr>
-      <p:grpSpPr/>
+      <p:grpSpPr>
+        <a:xfrm>
+          <a:off x="0" y="0"/>
+          <a:ext cx="0" cy="0"/>
+          <a:chOff x="0" y="0"/>
+          <a:chExt cx="0" cy="0"/>
+        </a:xfrm>
+      </p:grpSpPr>
       <p:sp>
         <p:nvSpPr>
           <p:cNvPr id="2" name="Rectangle 1"/>
@@ -23875,6 +24267,7 @@
           <a:lstStyle/>
           <a:p>
             <a:pPr algn="ctr"/>
+            <a:endParaRPr/>
           </a:p>
         </p:txBody>
       </p:sp>
@@ -23919,6 +24312,7 @@
           <a:lstStyle/>
           <a:p>
             <a:pPr algn="ctr"/>
+            <a:endParaRPr/>
           </a:p>
         </p:txBody>
       </p:sp>
@@ -24076,6 +24470,7 @@
           <a:lstStyle/>
           <a:p>
             <a:pPr algn="ctr"/>
+            <a:endParaRPr/>
           </a:p>
         </p:txBody>
       </p:sp>
@@ -24155,6 +24550,7 @@
           <a:lstStyle/>
           <a:p>
             <a:pPr algn="ctr"/>
+            <a:endParaRPr/>
           </a:p>
         </p:txBody>
       </p:sp>
@@ -24295,6 +24691,7 @@
           <a:lstStyle/>
           <a:p>
             <a:pPr algn="ctr"/>
+            <a:endParaRPr/>
           </a:p>
         </p:txBody>
       </p:sp>
@@ -24417,6 +24814,7 @@
           <a:lstStyle/>
           <a:p>
             <a:pPr algn="ctr"/>
+            <a:endParaRPr/>
           </a:p>
         </p:txBody>
       </p:sp>
@@ -24496,6 +24894,7 @@
           <a:lstStyle/>
           <a:p>
             <a:pPr algn="ctr"/>
+            <a:endParaRPr/>
           </a:p>
         </p:txBody>
       </p:sp>
@@ -24652,6 +25051,7 @@
           <a:lstStyle/>
           <a:p>
             <a:pPr algn="ctr"/>
+            <a:endParaRPr/>
           </a:p>
         </p:txBody>
       </p:sp>
@@ -24774,6 +25174,7 @@
           <a:lstStyle/>
           <a:p>
             <a:pPr algn="ctr"/>
+            <a:endParaRPr/>
           </a:p>
         </p:txBody>
       </p:sp>
@@ -24853,6 +25254,7 @@
           <a:lstStyle/>
           <a:p>
             <a:pPr algn="ctr"/>
+            <a:endParaRPr/>
           </a:p>
         </p:txBody>
       </p:sp>
@@ -24977,6 +25379,7 @@
           <a:lstStyle/>
           <a:p>
             <a:pPr algn="ctr"/>
+            <a:endParaRPr/>
           </a:p>
         </p:txBody>
       </p:sp>
@@ -25094,7 +25497,7 @@
 </file>
 
 <file path=ppt/slides/slide25.xml><?xml version="1.0" encoding="utf-8"?>
-<p:sld xmlns:a="http://schemas.openxmlformats.org/drawingml/2006/main" xmlns:p="http://schemas.openxmlformats.org/presentationml/2006/main" xmlns:r="http://schemas.openxmlformats.org/officeDocument/2006/relationships">
+<p:sld xmlns:a="http://schemas.openxmlformats.org/drawingml/2006/main" xmlns:r="http://schemas.openxmlformats.org/officeDocument/2006/relationships" xmlns:p="http://schemas.openxmlformats.org/presentationml/2006/main">
   <p:cSld>
     <p:spTree>
       <p:nvGrpSpPr>
@@ -25102,7 +25505,14 @@
         <p:cNvGrpSpPr/>
         <p:nvPr/>
       </p:nvGrpSpPr>
-      <p:grpSpPr/>
+      <p:grpSpPr>
+        <a:xfrm>
+          <a:off x="0" y="0"/>
+          <a:ext cx="0" cy="0"/>
+          <a:chOff x="0" y="0"/>
+          <a:chExt cx="0" cy="0"/>
+        </a:xfrm>
+      </p:grpSpPr>
       <p:sp>
         <p:nvSpPr>
           <p:cNvPr id="2" name="Rectangle 1"/>
@@ -25144,6 +25554,7 @@
           <a:lstStyle/>
           <a:p>
             <a:pPr algn="ctr"/>
+            <a:endParaRPr/>
           </a:p>
         </p:txBody>
       </p:sp>
@@ -25188,6 +25599,7 @@
           <a:lstStyle/>
           <a:p>
             <a:pPr algn="ctr"/>
+            <a:endParaRPr/>
           </a:p>
         </p:txBody>
       </p:sp>
@@ -25337,6 +25749,7 @@
           <a:lstStyle/>
           <a:p>
             <a:pPr algn="ctr"/>
+            <a:endParaRPr/>
           </a:p>
         </p:txBody>
       </p:sp>
@@ -25416,6 +25829,7 @@
           <a:lstStyle/>
           <a:p>
             <a:pPr algn="ctr"/>
+            <a:endParaRPr/>
           </a:p>
         </p:txBody>
       </p:sp>
@@ -25495,6 +25909,7 @@
           <a:lstStyle/>
           <a:p>
             <a:pPr algn="ctr"/>
+            <a:endParaRPr/>
           </a:p>
         </p:txBody>
       </p:sp>
@@ -25574,6 +25989,7 @@
           <a:lstStyle/>
           <a:p>
             <a:pPr algn="ctr"/>
+            <a:endParaRPr/>
           </a:p>
         </p:txBody>
       </p:sp>
@@ -25653,6 +26069,7 @@
           <a:lstStyle/>
           <a:p>
             <a:pPr algn="ctr"/>
+            <a:endParaRPr/>
           </a:p>
         </p:txBody>
       </p:sp>
@@ -25732,6 +26149,7 @@
           <a:lstStyle/>
           <a:p>
             <a:pPr algn="ctr"/>
+            <a:endParaRPr/>
           </a:p>
         </p:txBody>
       </p:sp>
@@ -25811,6 +26229,7 @@
           <a:lstStyle/>
           <a:p>
             <a:pPr algn="ctr"/>
+            <a:endParaRPr/>
           </a:p>
         </p:txBody>
       </p:sp>
@@ -25890,6 +26309,7 @@
           <a:lstStyle/>
           <a:p>
             <a:pPr algn="ctr"/>
+            <a:endParaRPr/>
           </a:p>
         </p:txBody>
       </p:sp>
@@ -25969,6 +26389,7 @@
           <a:lstStyle/>
           <a:p>
             <a:pPr algn="ctr"/>
+            <a:endParaRPr/>
           </a:p>
         </p:txBody>
       </p:sp>
@@ -26048,6 +26469,7 @@
           <a:lstStyle/>
           <a:p>
             <a:pPr algn="ctr"/>
+            <a:endParaRPr/>
           </a:p>
         </p:txBody>
       </p:sp>
@@ -26127,6 +26549,7 @@
           <a:lstStyle/>
           <a:p>
             <a:pPr algn="ctr"/>
+            <a:endParaRPr/>
           </a:p>
         </p:txBody>
       </p:sp>
@@ -26206,6 +26629,7 @@
           <a:lstStyle/>
           <a:p>
             <a:pPr algn="ctr"/>
+            <a:endParaRPr/>
           </a:p>
         </p:txBody>
       </p:sp>
@@ -26285,6 +26709,7 @@
           <a:lstStyle/>
           <a:p>
             <a:pPr algn="ctr"/>
+            <a:endParaRPr/>
           </a:p>
         </p:txBody>
       </p:sp>
@@ -26364,6 +26789,7 @@
           <a:lstStyle/>
           <a:p>
             <a:pPr algn="ctr"/>
+            <a:endParaRPr/>
           </a:p>
         </p:txBody>
       </p:sp>
@@ -26478,6 +26904,7 @@
           <a:lstStyle/>
           <a:p>
             <a:pPr algn="ctr"/>
+            <a:endParaRPr/>
           </a:p>
         </p:txBody>
       </p:sp>
@@ -26557,6 +26984,7 @@
           <a:lstStyle/>
           <a:p>
             <a:pPr algn="ctr"/>
+            <a:endParaRPr/>
           </a:p>
         </p:txBody>
       </p:sp>
@@ -26636,6 +27064,7 @@
           <a:lstStyle/>
           <a:p>
             <a:pPr algn="ctr"/>
+            <a:endParaRPr/>
           </a:p>
         </p:txBody>
       </p:sp>
@@ -26715,6 +27144,7 @@
           <a:lstStyle/>
           <a:p>
             <a:pPr algn="ctr"/>
+            <a:endParaRPr/>
           </a:p>
         </p:txBody>
       </p:sp>
@@ -26797,7 +27227,7 @@
 </file>
 
 <file path=ppt/slides/slide3.xml><?xml version="1.0" encoding="utf-8"?>
-<p:sld xmlns:a="http://schemas.openxmlformats.org/drawingml/2006/main" xmlns:p="http://schemas.openxmlformats.org/presentationml/2006/main" xmlns:r="http://schemas.openxmlformats.org/officeDocument/2006/relationships">
+<p:sld xmlns:a="http://schemas.openxmlformats.org/drawingml/2006/main" xmlns:r="http://schemas.openxmlformats.org/officeDocument/2006/relationships" xmlns:p="http://schemas.openxmlformats.org/presentationml/2006/main">
   <p:cSld>
     <p:spTree>
       <p:nvGrpSpPr>
@@ -26805,7 +27235,14 @@
         <p:cNvGrpSpPr/>
         <p:nvPr/>
       </p:nvGrpSpPr>
-      <p:grpSpPr/>
+      <p:grpSpPr>
+        <a:xfrm>
+          <a:off x="0" y="0"/>
+          <a:ext cx="0" cy="0"/>
+          <a:chOff x="0" y="0"/>
+          <a:chExt cx="0" cy="0"/>
+        </a:xfrm>
+      </p:grpSpPr>
       <p:sp>
         <p:nvSpPr>
           <p:cNvPr id="2" name="Rectangle 1"/>
@@ -26847,6 +27284,7 @@
           <a:lstStyle/>
           <a:p>
             <a:pPr algn="ctr"/>
+            <a:endParaRPr/>
           </a:p>
         </p:txBody>
       </p:sp>
@@ -26891,6 +27329,7 @@
           <a:lstStyle/>
           <a:p>
             <a:pPr algn="ctr"/>
+            <a:endParaRPr/>
           </a:p>
         </p:txBody>
       </p:sp>
@@ -27075,6 +27514,7 @@
           <a:lstStyle/>
           <a:p>
             <a:pPr algn="ctr"/>
+            <a:endParaRPr/>
           </a:p>
         </p:txBody>
       </p:sp>
@@ -27285,6 +27725,7 @@
           <a:lstStyle/>
           <a:p>
             <a:pPr algn="ctr"/>
+            <a:endParaRPr/>
           </a:p>
         </p:txBody>
       </p:sp>
@@ -27364,6 +27805,7 @@
           <a:lstStyle/>
           <a:p>
             <a:pPr algn="ctr"/>
+            <a:endParaRPr/>
           </a:p>
         </p:txBody>
       </p:sp>
@@ -27443,6 +27885,7 @@
           <a:lstStyle/>
           <a:p>
             <a:pPr algn="ctr"/>
+            <a:endParaRPr/>
           </a:p>
         </p:txBody>
       </p:sp>
@@ -27522,6 +27965,7 @@
           <a:lstStyle/>
           <a:p>
             <a:pPr algn="ctr"/>
+            <a:endParaRPr/>
           </a:p>
         </p:txBody>
       </p:sp>
@@ -27601,6 +28045,7 @@
           <a:lstStyle/>
           <a:p>
             <a:pPr algn="ctr"/>
+            <a:endParaRPr/>
           </a:p>
         </p:txBody>
       </p:sp>
@@ -27680,6 +28125,7 @@
           <a:lstStyle/>
           <a:p>
             <a:pPr algn="ctr"/>
+            <a:endParaRPr/>
           </a:p>
         </p:txBody>
       </p:sp>
@@ -27761,6 +28207,7 @@
           <a:lstStyle/>
           <a:p>
             <a:pPr algn="ctr"/>
+            <a:endParaRPr/>
           </a:p>
         </p:txBody>
       </p:sp>
@@ -27917,7 +28364,7 @@
 </file>
 
 <file path=ppt/slides/slide4.xml><?xml version="1.0" encoding="utf-8"?>
-<p:sld xmlns:a="http://schemas.openxmlformats.org/drawingml/2006/main" xmlns:p="http://schemas.openxmlformats.org/presentationml/2006/main" xmlns:r="http://schemas.openxmlformats.org/officeDocument/2006/relationships">
+<p:sld xmlns:a="http://schemas.openxmlformats.org/drawingml/2006/main" xmlns:r="http://schemas.openxmlformats.org/officeDocument/2006/relationships" xmlns:p="http://schemas.openxmlformats.org/presentationml/2006/main">
   <p:cSld>
     <p:spTree>
       <p:nvGrpSpPr>
@@ -27925,7 +28372,14 @@
         <p:cNvGrpSpPr/>
         <p:nvPr/>
       </p:nvGrpSpPr>
-      <p:grpSpPr/>
+      <p:grpSpPr>
+        <a:xfrm>
+          <a:off x="0" y="0"/>
+          <a:ext cx="0" cy="0"/>
+          <a:chOff x="0" y="0"/>
+          <a:chExt cx="0" cy="0"/>
+        </a:xfrm>
+      </p:grpSpPr>
       <p:sp>
         <p:nvSpPr>
           <p:cNvPr id="2" name="Rectangle 1"/>
@@ -27967,6 +28421,7 @@
           <a:lstStyle/>
           <a:p>
             <a:pPr algn="ctr"/>
+            <a:endParaRPr/>
           </a:p>
         </p:txBody>
       </p:sp>
@@ -28011,6 +28466,7 @@
           <a:lstStyle/>
           <a:p>
             <a:pPr algn="ctr"/>
+            <a:endParaRPr/>
           </a:p>
         </p:txBody>
       </p:sp>
@@ -28162,6 +28618,7 @@
           <a:lstStyle/>
           <a:p>
             <a:pPr algn="ctr"/>
+            <a:endParaRPr/>
           </a:p>
         </p:txBody>
       </p:sp>
@@ -28279,6 +28736,7 @@
           <a:lstStyle/>
           <a:p>
             <a:pPr algn="ctr"/>
+            <a:endParaRPr/>
           </a:p>
         </p:txBody>
       </p:sp>
@@ -28396,6 +28854,7 @@
           <a:lstStyle/>
           <a:p>
             <a:pPr algn="ctr"/>
+            <a:endParaRPr/>
           </a:p>
         </p:txBody>
       </p:sp>
@@ -28513,6 +28972,7 @@
           <a:lstStyle/>
           <a:p>
             <a:pPr algn="ctr"/>
+            <a:endParaRPr/>
           </a:p>
         </p:txBody>
       </p:sp>
@@ -28630,6 +29090,7 @@
           <a:lstStyle/>
           <a:p>
             <a:pPr algn="ctr"/>
+            <a:endParaRPr/>
           </a:p>
         </p:txBody>
       </p:sp>
@@ -28747,6 +29208,7 @@
           <a:lstStyle/>
           <a:p>
             <a:pPr algn="ctr"/>
+            <a:endParaRPr/>
           </a:p>
         </p:txBody>
       </p:sp>
@@ -28826,6 +29288,7 @@
           <a:lstStyle/>
           <a:p>
             <a:pPr algn="ctr"/>
+            <a:endParaRPr/>
           </a:p>
         </p:txBody>
       </p:sp>
@@ -28917,6 +29380,7 @@
           <a:lstStyle/>
           <a:p>
             <a:pPr algn="ctr"/>
+            <a:endParaRPr/>
           </a:p>
         </p:txBody>
       </p:sp>
@@ -28961,6 +29425,7 @@
           <a:lstStyle/>
           <a:p>
             <a:pPr algn="ctr"/>
+            <a:endParaRPr/>
           </a:p>
         </p:txBody>
       </p:sp>
@@ -29087,6 +29552,7 @@
           <a:lstStyle/>
           <a:p>
             <a:pPr algn="ctr"/>
+            <a:endParaRPr/>
           </a:p>
         </p:txBody>
       </p:sp>
@@ -29131,6 +29597,7 @@
           <a:lstStyle/>
           <a:p>
             <a:pPr algn="ctr"/>
+            <a:endParaRPr/>
           </a:p>
         </p:txBody>
       </p:sp>
@@ -29257,6 +29724,7 @@
           <a:lstStyle/>
           <a:p>
             <a:pPr algn="ctr"/>
+            <a:endParaRPr/>
           </a:p>
         </p:txBody>
       </p:sp>
@@ -29301,6 +29769,7 @@
           <a:lstStyle/>
           <a:p>
             <a:pPr algn="ctr"/>
+            <a:endParaRPr/>
           </a:p>
         </p:txBody>
       </p:sp>
@@ -29422,7 +29891,7 @@
 </file>
 
 <file path=ppt/slides/slide5.xml><?xml version="1.0" encoding="utf-8"?>
-<p:sld xmlns:a="http://schemas.openxmlformats.org/drawingml/2006/main" xmlns:p="http://schemas.openxmlformats.org/presentationml/2006/main" xmlns:r="http://schemas.openxmlformats.org/officeDocument/2006/relationships">
+<p:sld xmlns:a="http://schemas.openxmlformats.org/drawingml/2006/main" xmlns:r="http://schemas.openxmlformats.org/officeDocument/2006/relationships" xmlns:p="http://schemas.openxmlformats.org/presentationml/2006/main">
   <p:cSld>
     <p:spTree>
       <p:nvGrpSpPr>
@@ -29430,7 +29899,14 @@
         <p:cNvGrpSpPr/>
         <p:nvPr/>
       </p:nvGrpSpPr>
-      <p:grpSpPr/>
+      <p:grpSpPr>
+        <a:xfrm>
+          <a:off x="0" y="0"/>
+          <a:ext cx="0" cy="0"/>
+          <a:chOff x="0" y="0"/>
+          <a:chExt cx="0" cy="0"/>
+        </a:xfrm>
+      </p:grpSpPr>
       <p:sp>
         <p:nvSpPr>
           <p:cNvPr id="2" name="Rectangle 1"/>
@@ -29472,6 +29948,7 @@
           <a:lstStyle/>
           <a:p>
             <a:pPr algn="ctr"/>
+            <a:endParaRPr/>
           </a:p>
         </p:txBody>
       </p:sp>
@@ -29516,6 +29993,7 @@
           <a:lstStyle/>
           <a:p>
             <a:pPr algn="ctr"/>
+            <a:endParaRPr/>
           </a:p>
         </p:txBody>
       </p:sp>
@@ -30008,7 +30486,7 @@
 </file>
 
 <file path=ppt/slides/slide6.xml><?xml version="1.0" encoding="utf-8"?>
-<p:sld xmlns:a="http://schemas.openxmlformats.org/drawingml/2006/main" xmlns:p="http://schemas.openxmlformats.org/presentationml/2006/main" xmlns:r="http://schemas.openxmlformats.org/officeDocument/2006/relationships">
+<p:sld xmlns:a="http://schemas.openxmlformats.org/drawingml/2006/main" xmlns:r="http://schemas.openxmlformats.org/officeDocument/2006/relationships" xmlns:p="http://schemas.openxmlformats.org/presentationml/2006/main">
   <p:cSld>
     <p:spTree>
       <p:nvGrpSpPr>
@@ -30016,7 +30494,14 @@
         <p:cNvGrpSpPr/>
         <p:nvPr/>
       </p:nvGrpSpPr>
-      <p:grpSpPr/>
+      <p:grpSpPr>
+        <a:xfrm>
+          <a:off x="0" y="0"/>
+          <a:ext cx="0" cy="0"/>
+          <a:chOff x="0" y="0"/>
+          <a:chExt cx="0" cy="0"/>
+        </a:xfrm>
+      </p:grpSpPr>
       <p:sp>
         <p:nvSpPr>
           <p:cNvPr id="2" name="Rectangle 1"/>
@@ -30058,6 +30543,7 @@
           <a:lstStyle/>
           <a:p>
             <a:pPr algn="ctr"/>
+            <a:endParaRPr/>
           </a:p>
         </p:txBody>
       </p:sp>
@@ -30102,6 +30588,7 @@
           <a:lstStyle/>
           <a:p>
             <a:pPr algn="ctr"/>
+            <a:endParaRPr/>
           </a:p>
         </p:txBody>
       </p:sp>
@@ -30259,6 +30746,7 @@
           <a:lstStyle/>
           <a:p>
             <a:pPr algn="ctr"/>
+            <a:endParaRPr/>
           </a:p>
         </p:txBody>
       </p:sp>
@@ -30303,6 +30791,7 @@
           <a:lstStyle/>
           <a:p>
             <a:pPr algn="ctr"/>
+            <a:endParaRPr/>
           </a:p>
         </p:txBody>
       </p:sp>
@@ -30445,6 +30934,7 @@
           <a:lstStyle/>
           <a:p>
             <a:pPr algn="ctr"/>
+            <a:endParaRPr/>
           </a:p>
         </p:txBody>
       </p:sp>
@@ -30489,6 +30979,7 @@
           <a:lstStyle/>
           <a:p>
             <a:pPr algn="ctr"/>
+            <a:endParaRPr/>
           </a:p>
         </p:txBody>
       </p:sp>
@@ -30631,6 +31122,7 @@
           <a:lstStyle/>
           <a:p>
             <a:pPr algn="ctr"/>
+            <a:endParaRPr/>
           </a:p>
         </p:txBody>
       </p:sp>
@@ -30675,6 +31167,7 @@
           <a:lstStyle/>
           <a:p>
             <a:pPr algn="ctr"/>
+            <a:endParaRPr/>
           </a:p>
         </p:txBody>
       </p:sp>
@@ -30817,6 +31310,7 @@
           <a:lstStyle/>
           <a:p>
             <a:pPr algn="ctr"/>
+            <a:endParaRPr/>
           </a:p>
         </p:txBody>
       </p:sp>
@@ -30861,6 +31355,7 @@
           <a:lstStyle/>
           <a:p>
             <a:pPr algn="ctr"/>
+            <a:endParaRPr/>
           </a:p>
         </p:txBody>
       </p:sp>
@@ -31003,6 +31498,7 @@
           <a:lstStyle/>
           <a:p>
             <a:pPr algn="ctr"/>
+            <a:endParaRPr/>
           </a:p>
         </p:txBody>
       </p:sp>
@@ -31047,6 +31543,7 @@
           <a:lstStyle/>
           <a:p>
             <a:pPr algn="ctr"/>
+            <a:endParaRPr/>
           </a:p>
         </p:txBody>
       </p:sp>
@@ -31184,7 +31681,7 @@
 </file>
 
 <file path=ppt/slides/slide7.xml><?xml version="1.0" encoding="utf-8"?>
-<p:sld xmlns:a="http://schemas.openxmlformats.org/drawingml/2006/main" xmlns:p="http://schemas.openxmlformats.org/presentationml/2006/main" xmlns:r="http://schemas.openxmlformats.org/officeDocument/2006/relationships">
+<p:sld xmlns:a="http://schemas.openxmlformats.org/drawingml/2006/main" xmlns:r="http://schemas.openxmlformats.org/officeDocument/2006/relationships" xmlns:p="http://schemas.openxmlformats.org/presentationml/2006/main">
   <p:cSld>
     <p:spTree>
       <p:nvGrpSpPr>
@@ -31192,7 +31689,14 @@
         <p:cNvGrpSpPr/>
         <p:nvPr/>
       </p:nvGrpSpPr>
-      <p:grpSpPr/>
+      <p:grpSpPr>
+        <a:xfrm>
+          <a:off x="0" y="0"/>
+          <a:ext cx="0" cy="0"/>
+          <a:chOff x="0" y="0"/>
+          <a:chExt cx="0" cy="0"/>
+        </a:xfrm>
+      </p:grpSpPr>
       <p:sp>
         <p:nvSpPr>
           <p:cNvPr id="2" name="Rectangle 1"/>
@@ -31234,6 +31738,7 @@
           <a:lstStyle/>
           <a:p>
             <a:pPr algn="ctr"/>
+            <a:endParaRPr/>
           </a:p>
         </p:txBody>
       </p:sp>
@@ -31278,6 +31783,7 @@
           <a:lstStyle/>
           <a:p>
             <a:pPr algn="ctr"/>
+            <a:endParaRPr/>
           </a:p>
         </p:txBody>
       </p:sp>
@@ -31435,6 +31941,7 @@
           <a:lstStyle/>
           <a:p>
             <a:pPr algn="ctr"/>
+            <a:endParaRPr/>
           </a:p>
         </p:txBody>
       </p:sp>
@@ -31511,6 +32018,7 @@
           <a:lstStyle/>
           <a:p>
             <a:pPr algn="ctr"/>
+            <a:endParaRPr/>
           </a:p>
         </p:txBody>
       </p:sp>
@@ -31555,6 +32063,7 @@
           <a:lstStyle/>
           <a:p>
             <a:pPr algn="ctr"/>
+            <a:endParaRPr/>
           </a:p>
         </p:txBody>
       </p:sp>
@@ -31681,6 +32190,7 @@
           <a:lstStyle/>
           <a:p>
             <a:pPr algn="ctr"/>
+            <a:endParaRPr/>
           </a:p>
         </p:txBody>
       </p:sp>
@@ -31725,6 +32235,7 @@
           <a:lstStyle/>
           <a:p>
             <a:pPr algn="ctr"/>
+            <a:endParaRPr/>
           </a:p>
         </p:txBody>
       </p:sp>
@@ -31851,6 +32362,7 @@
           <a:lstStyle/>
           <a:p>
             <a:pPr algn="ctr"/>
+            <a:endParaRPr/>
           </a:p>
         </p:txBody>
       </p:sp>
@@ -31895,6 +32407,7 @@
           <a:lstStyle/>
           <a:p>
             <a:pPr algn="ctr"/>
+            <a:endParaRPr/>
           </a:p>
         </p:txBody>
       </p:sp>
@@ -32021,6 +32534,7 @@
           <a:lstStyle/>
           <a:p>
             <a:pPr algn="ctr"/>
+            <a:endParaRPr/>
           </a:p>
         </p:txBody>
       </p:sp>
@@ -32065,6 +32579,7 @@
           <a:lstStyle/>
           <a:p>
             <a:pPr algn="ctr"/>
+            <a:endParaRPr/>
           </a:p>
         </p:txBody>
       </p:sp>
@@ -32186,7 +32701,7 @@
 </file>
 
 <file path=ppt/slides/slide8.xml><?xml version="1.0" encoding="utf-8"?>
-<p:sld xmlns:a="http://schemas.openxmlformats.org/drawingml/2006/main" xmlns:p="http://schemas.openxmlformats.org/presentationml/2006/main" xmlns:r="http://schemas.openxmlformats.org/officeDocument/2006/relationships">
+<p:sld xmlns:a="http://schemas.openxmlformats.org/drawingml/2006/main" xmlns:r="http://schemas.openxmlformats.org/officeDocument/2006/relationships" xmlns:p="http://schemas.openxmlformats.org/presentationml/2006/main">
   <p:cSld>
     <p:spTree>
       <p:nvGrpSpPr>
@@ -32194,7 +32709,14 @@
         <p:cNvGrpSpPr/>
         <p:nvPr/>
       </p:nvGrpSpPr>
-      <p:grpSpPr/>
+      <p:grpSpPr>
+        <a:xfrm>
+          <a:off x="0" y="0"/>
+          <a:ext cx="0" cy="0"/>
+          <a:chOff x="0" y="0"/>
+          <a:chExt cx="0" cy="0"/>
+        </a:xfrm>
+      </p:grpSpPr>
       <p:sp>
         <p:nvSpPr>
           <p:cNvPr id="2" name="Rectangle 1"/>
@@ -32236,6 +32758,7 @@
           <a:lstStyle/>
           <a:p>
             <a:pPr algn="ctr"/>
+            <a:endParaRPr/>
           </a:p>
         </p:txBody>
       </p:sp>
@@ -32280,6 +32803,7 @@
           <a:lstStyle/>
           <a:p>
             <a:pPr algn="ctr"/>
+            <a:endParaRPr/>
           </a:p>
         </p:txBody>
       </p:sp>
@@ -32437,6 +32961,7 @@
           <a:lstStyle/>
           <a:p>
             <a:pPr algn="ctr"/>
+            <a:endParaRPr/>
           </a:p>
         </p:txBody>
       </p:sp>
@@ -32483,6 +33008,7 @@
           <a:lstStyle/>
           <a:p>
             <a:pPr algn="ctr"/>
+            <a:endParaRPr/>
           </a:p>
         </p:txBody>
       </p:sp>
@@ -32597,6 +33123,7 @@
           <a:lstStyle/>
           <a:p>
             <a:pPr algn="ctr"/>
+            <a:endParaRPr/>
           </a:p>
         </p:txBody>
       </p:sp>
@@ -32715,6 +33242,7 @@
           <a:lstStyle/>
           <a:p>
             <a:pPr algn="ctr"/>
+            <a:endParaRPr/>
           </a:p>
         </p:txBody>
       </p:sp>
@@ -32867,6 +33395,7 @@
           <a:lstStyle/>
           <a:p>
             <a:pPr algn="ctr"/>
+            <a:endParaRPr/>
           </a:p>
         </p:txBody>
       </p:sp>
@@ -32984,6 +33513,7 @@
           <a:lstStyle/>
           <a:p>
             <a:pPr algn="ctr"/>
+            <a:endParaRPr/>
           </a:p>
         </p:txBody>
       </p:sp>
@@ -33173,6 +33703,7 @@
           <a:lstStyle/>
           <a:p>
             <a:pPr algn="ctr"/>
+            <a:endParaRPr/>
           </a:p>
         </p:txBody>
       </p:sp>
@@ -33371,6 +33902,7 @@
           <a:lstStyle/>
           <a:p>
             <a:pPr algn="ctr"/>
+            <a:endParaRPr/>
           </a:p>
         </p:txBody>
       </p:sp>
@@ -33450,6 +33982,7 @@
           <a:lstStyle/>
           <a:p>
             <a:pPr algn="ctr"/>
+            <a:endParaRPr/>
           </a:p>
         </p:txBody>
       </p:sp>
@@ -33529,6 +34062,7 @@
           <a:lstStyle/>
           <a:p>
             <a:pPr algn="ctr"/>
+            <a:endParaRPr/>
           </a:p>
         </p:txBody>
       </p:sp>
@@ -33611,7 +34145,7 @@
 </file>
 
 <file path=ppt/slides/slide9.xml><?xml version="1.0" encoding="utf-8"?>
-<p:sld xmlns:a="http://schemas.openxmlformats.org/drawingml/2006/main" xmlns:p="http://schemas.openxmlformats.org/presentationml/2006/main" xmlns:r="http://schemas.openxmlformats.org/officeDocument/2006/relationships">
+<p:sld xmlns:a="http://schemas.openxmlformats.org/drawingml/2006/main" xmlns:r="http://schemas.openxmlformats.org/officeDocument/2006/relationships" xmlns:p="http://schemas.openxmlformats.org/presentationml/2006/main">
   <p:cSld>
     <p:spTree>
       <p:nvGrpSpPr>
@@ -33619,7 +34153,14 @@
         <p:cNvGrpSpPr/>
         <p:nvPr/>
       </p:nvGrpSpPr>
-      <p:grpSpPr/>
+      <p:grpSpPr>
+        <a:xfrm>
+          <a:off x="0" y="0"/>
+          <a:ext cx="0" cy="0"/>
+          <a:chOff x="0" y="0"/>
+          <a:chExt cx="0" cy="0"/>
+        </a:xfrm>
+      </p:grpSpPr>
       <p:sp>
         <p:nvSpPr>
           <p:cNvPr id="2" name="Rectangle 1"/>
@@ -33661,6 +34202,7 @@
           <a:lstStyle/>
           <a:p>
             <a:pPr algn="ctr"/>
+            <a:endParaRPr/>
           </a:p>
         </p:txBody>
       </p:sp>
@@ -33705,6 +34247,7 @@
           <a:lstStyle/>
           <a:p>
             <a:pPr algn="ctr"/>
+            <a:endParaRPr/>
           </a:p>
         </p:txBody>
       </p:sp>
@@ -33862,6 +34405,7 @@
           <a:lstStyle/>
           <a:p>
             <a:pPr algn="ctr"/>
+            <a:endParaRPr/>
           </a:p>
         </p:txBody>
       </p:sp>
@@ -34004,6 +34548,7 @@
           <a:lstStyle/>
           <a:p>
             <a:pPr algn="ctr"/>
+            <a:endParaRPr/>
           </a:p>
         </p:txBody>
       </p:sp>
@@ -34080,6 +34625,7 @@
           <a:lstStyle/>
           <a:p>
             <a:pPr algn="ctr"/>
+            <a:endParaRPr/>
           </a:p>
         </p:txBody>
       </p:sp>
@@ -34222,6 +34768,7 @@
           <a:lstStyle/>
           <a:p>
             <a:pPr algn="ctr"/>
+            <a:endParaRPr/>
           </a:p>
         </p:txBody>
       </p:sp>
@@ -34298,6 +34845,7 @@
           <a:lstStyle/>
           <a:p>
             <a:pPr algn="ctr"/>
+            <a:endParaRPr/>
           </a:p>
         </p:txBody>
       </p:sp>
@@ -34440,6 +34988,7 @@
           <a:lstStyle/>
           <a:p>
             <a:pPr algn="ctr"/>
+            <a:endParaRPr/>
           </a:p>
         </p:txBody>
       </p:sp>

</xml_diff>